<commit_message>
Soluzioni L1 e L2: = e ==
Co-Authored-By: Claude Opus 5.5 <noreply@anthropic.com>
Claude-Session: https://claude.ai/code/session_014CzWDFXvYNxqLeD99LSN3G
</commit_message>
<xml_diff>
--- a/L01_python_calcolatrice/slide_complete.pptx
+++ b/L01_python_calcolatrice/slide_complete.pptx
@@ -19,9 +19,10 @@
     <p:sldId id="267" r:id="rId13"/>
     <p:sldId id="268" r:id="rId14"/>
     <p:sldId id="269" r:id="rId15"/>
+    <p:sldId id="270" r:id="rId16"/>
   </p:sldIdLst>
   <p:notesMasterIdLst>
-    <p:notesMasterId r:id="rId16"/>
+    <p:notesMasterId r:id="rId17"/>
   </p:notesMasterIdLst>
   <p:sldSz cx="12192000" cy="6858000"/>
   <p:notesSz cx="6858000" cy="12192000"/>
@@ -120,13 +121,13 @@
   <p:extLst>
     <p:ext uri="{521415D9-36F7-43E2-AB2F-B90AF26B5E84}">
       <p14:sectionLst xmlns:p14="http://schemas.microsoft.com/office/powerpoint/2010/main">
-        <p14:section name="Apertura" id="{10794a69-79b0-5c53-fb43-4b2a729962b8}">
+        <p14:section name="Apertura" id="{6cd74bd4-a3aa-3733-d989-3bc8ec6e1f5d}">
           <p14:sldIdLst>
             <p14:sldId id="256"/>
             <p14:sldId id="257"/>
           </p14:sldIdLst>
         </p14:section>
-        <p14:section name="Spiegazione" id="{b5d8d5be-c70b-c14f-175d-f1a104ac1011}">
+        <p14:section name="Spiegazione" id="{35d3c0de-c446-ebcb-a356-2fd13233009f}">
           <p14:sldIdLst>
             <p14:sldId id="258"/>
             <p14:sldId id="259"/>
@@ -135,23 +136,24 @@
             <p14:sldId id="262"/>
           </p14:sldIdLst>
         </p14:section>
-        <p14:section name="Task" id="{da8db15b-82ac-46a6-e28a-fa7296f4c775}">
+        <p14:section name="Task" id="{24f44e97-6b2c-65ef-3e7d-a594b4e581d4}">
           <p14:sldIdLst>
             <p14:sldId id="263"/>
           </p14:sldIdLst>
         </p14:section>
-        <p14:section name="Debrief" id="{886e6c92-aca4-8ede-37ab-4ddb9130f34a}">
+        <p14:section name="Debrief" id="{86f19fdd-8797-748b-18e4-e2b62056a455}">
           <p14:sldIdLst>
             <p14:sldId id="264"/>
             <p14:sldId id="265"/>
             <p14:sldId id="266"/>
             <p14:sldId id="267"/>
             <p14:sldId id="268"/>
+            <p14:sldId id="269"/>
           </p14:sldIdLst>
         </p14:section>
-        <p14:section name="Chiusura" id="{39769e4a-cb05-ffa8-cb8f-8cd95c665632}">
+        <p14:section name="Chiusura" id="{a2031043-637a-5a0e-5c40-755637e91ed2}">
           <p14:sldIdLst>
-            <p14:sldId id="269"/>
+            <p14:sldId id="270"/>
           </p14:sldIdLst>
         </p14:section>
       </p14:sectionLst>
@@ -734,7 +736,7 @@
           <a:p>
             <a:r>
               <a:rPr lang="en-US" dirty="0"/>
-              <a:t>La virgola decimale tornerà fuori con l'Excel (L2-L3): anticiparlo qui.</a:t>
+              <a:t>Chi ha provato montante = 6400? Cosa è successo dopo, nella frase del passo 5 rieseguita? Collegare all'ordine di esecuzione delle celle. Questo == tornerà nella L2 nei filtri: df[df['anno'] == 2020].</a:t>
             </a:r>
             <a:endParaRPr lang="en-US" dirty="0"/>
           </a:p>
@@ -822,7 +824,7 @@
           <a:p>
             <a:r>
               <a:rPr lang="en-US" dirty="0"/>
-              <a:t>Chiedere: chi se n'è accorto? Chi ha pensato che fosse giusto? Collegare a Gemini: anche il codice generato può fare esattamente questo.</a:t>
+              <a:t>La virgola decimale tornerà fuori con l'Excel (L2-L3): anticiparlo qui.</a:t>
             </a:r>
             <a:endParaRPr lang="en-US" dirty="0"/>
           </a:p>
@@ -910,7 +912,7 @@
           <a:p>
             <a:r>
               <a:rPr lang="en-US" dirty="0"/>
-              <a:t>Chi l'ha risolto cercando l'errore su Google? Chi con Gemini? Le soluzioni erano uguali?</a:t>
+              <a:t>Chiedere: chi se n'è accorto? Chi ha pensato che fosse giusto? Collegare a Gemini: anche il codice generato può fare esattamente questo.</a:t>
             </a:r>
             <a:endParaRPr lang="en-US" dirty="0"/>
           </a:p>
@@ -998,7 +1000,7 @@
           <a:p>
             <a:r>
               <a:rPr lang="en-US" dirty="0"/>
-              <a:t>Il problema dei tipi tornerà con l'Excel. Ricordare di creare l'account Kaggle.</a:t>
+              <a:t>Chi l'ha risolto cercando l'errore su Google? Chi con Gemini? Le soluzioni erano uguali?</a:t>
             </a:r>
             <a:endParaRPr lang="en-US" dirty="0"/>
           </a:p>
@@ -1022,6 +1024,94 @@
             <a:fld id="{F7021451-1387-4CA6-816F-3879F97B5CBC}" type="slidenum">
               <a:rPr lang="en-US"/>
               <a:t>14</a:t>
+            </a:fld>
+            <a:endParaRPr lang="en-US"/>
+          </a:p>
+        </p:txBody>
+      </p:sp>
+    </p:spTree>
+    <p:extLst>
+      <p:ext uri="{BB962C8B-B14F-4D97-AF65-F5344CB8AC3E}">
+        <p14:creationId xmlns:p14="http://schemas.microsoft.com/office/powerpoint/2010/main" val="1024086991"/>
+      </p:ext>
+    </p:extLst>
+  </p:cSld>
+  <p:clrMapOvr>
+    <a:masterClrMapping/>
+  </p:clrMapOvr>
+</p:notes>
+</file>
+
+<file path=ppt/notesSlides/notesSlide15.xml><?xml version="1.0" encoding="utf-8"?>
+<p:notes xmlns:a="http://schemas.openxmlformats.org/drawingml/2006/main" xmlns:r="http://schemas.openxmlformats.org/officeDocument/2006/relationships" xmlns:p="http://schemas.openxmlformats.org/presentationml/2006/main">
+  <p:cSld>
+    <p:spTree>
+      <p:nvGrpSpPr>
+        <p:cNvPr id="1" name=""/>
+        <p:cNvGrpSpPr/>
+        <p:nvPr/>
+      </p:nvGrpSpPr>
+      <p:grpSpPr>
+        <a:xfrm>
+          <a:off x="0" y="0"/>
+          <a:ext cx="0" cy="0"/>
+          <a:chOff x="0" y="0"/>
+          <a:chExt cx="0" cy="0"/>
+        </a:xfrm>
+      </p:grpSpPr>
+      <p:sp>
+        <p:nvSpPr>
+          <p:cNvPr id="2" name="Slide Image Placeholder 1"/>
+          <p:cNvSpPr>
+            <a:spLocks noGrp="1" noRot="1" noChangeAspect="1"/>
+          </p:cNvSpPr>
+          <p:nvPr>
+            <p:ph type="sldImg"/>
+          </p:nvPr>
+        </p:nvSpPr>
+        <p:spPr/>
+      </p:sp>
+      <p:sp>
+        <p:nvSpPr>
+          <p:cNvPr id="3" name="Notes Placeholder 2"/>
+          <p:cNvSpPr>
+            <a:spLocks noGrp="1"/>
+          </p:cNvSpPr>
+          <p:nvPr>
+            <p:ph type="body" idx="1"/>
+          </p:nvPr>
+        </p:nvSpPr>
+        <p:spPr/>
+        <p:txBody>
+          <a:bodyPr/>
+          <a:lstStyle/>
+          <a:p>
+            <a:r>
+              <a:rPr lang="en-US" dirty="0"/>
+              <a:t>Il problema dei tipi tornerà con l'Excel. Ricordare di creare l'account Kaggle.</a:t>
+            </a:r>
+            <a:endParaRPr lang="en-US" dirty="0"/>
+          </a:p>
+        </p:txBody>
+      </p:sp>
+      <p:sp>
+        <p:nvSpPr>
+          <p:cNvPr id="4" name="Slide Number Placeholder 3"/>
+          <p:cNvSpPr>
+            <a:spLocks noGrp="1"/>
+          </p:cNvSpPr>
+          <p:nvPr>
+            <p:ph type="sldNum" sz="quarter" idx="10"/>
+          </p:nvPr>
+        </p:nvSpPr>
+        <p:spPr/>
+        <p:txBody>
+          <a:bodyPr/>
+          <a:lstStyle/>
+          <a:p>
+            <a:fld id="{F7021451-1387-4CA6-816F-3879F97B5CBC}" type="slidenum">
+              <a:rPr lang="en-US"/>
+              <a:t>15</a:t>
             </a:fld>
             <a:endParaRPr lang="en-US"/>
           </a:p>
@@ -1614,7 +1704,7 @@
           <a:p>
             <a:r>
               <a:rPr lang="en-US" dirty="0"/>
-              <a:t>Durante il task: girare tra i banchi, segnarsi le soluzioni interessanti (anche sbagliate) da mostrare nel debrief. Al passo 6 molti non capiranno: è voluto.</a:t>
+              <a:t>Durante il task: girare tra i banchi, segnarsi le soluzioni interessanti (anche sbagliate) da mostrare nel debrief. Al passo 7 molti non capiranno: è voluto.</a:t>
             </a:r>
             <a:endParaRPr lang="en-US" dirty="0"/>
           </a:p>
@@ -3138,6 +3228,735 @@
                   <a:srgbClr val="0F4C5C"/>
                 </a:solidFill>
               </a:rPr>
+              <a:t>= mette, == chiede</a:t>
+            </a:r>
+            <a:endParaRPr lang="en-US" sz="3600" dirty="0"/>
+          </a:p>
+        </p:txBody>
+      </p:sp>
+      <p:sp>
+        <p:nvSpPr>
+          <p:cNvPr id="3" name="Text 1"/>
+          <p:cNvSpPr txBox="1"/>
+          <p:nvPr/>
+        </p:nvSpPr>
+        <p:spPr>
+          <a:xfrm>
+            <a:off x="548640" y="1600200"/>
+            <a:ext cx="5349240" cy="548640"/>
+          </a:xfrm>
+          <a:prstGeom prst="rect">
+            <a:avLst/>
+          </a:prstGeom>
+          <a:noFill/>
+          <a:ln/>
+        </p:spPr>
+        <p:txBody>
+          <a:bodyPr wrap="square" lIns="0" tIns="0" rIns="0" bIns="0" rtlCol="0" anchor="ctr"/>
+          <a:lstStyle/>
+          <a:p>
+            <a:pPr indent="0" marL="0">
+              <a:buNone/>
+            </a:pPr>
+            <a:r>
+              <a:rPr lang="en-US" sz="2800" b="1" dirty="0">
+                <a:solidFill>
+                  <a:srgbClr val="8F5308"/>
+                </a:solidFill>
+                <a:latin typeface="Courier New" pitchFamily="34" charset="0"/>
+                <a:ea typeface="Courier New" pitchFamily="34" charset="-122"/>
+                <a:cs typeface="Courier New" pitchFamily="34" charset="-120"/>
+              </a:rPr>
+              <a:t>=</a:t>
+            </a:r>
+            <a:pPr indent="0" marL="0">
+              <a:buNone/>
+            </a:pPr>
+            <a:r>
+              <a:rPr lang="en-US" sz="2800" b="1" dirty="0">
+                <a:solidFill>
+                  <a:srgbClr val="0F4C5C"/>
+                </a:solidFill>
+              </a:rPr>
+              <a:t>  assegnazione</a:t>
+            </a:r>
+            <a:endParaRPr lang="en-US" sz="2800" dirty="0"/>
+          </a:p>
+        </p:txBody>
+      </p:sp>
+      <p:sp>
+        <p:nvSpPr>
+          <p:cNvPr id="4" name="Text 2"/>
+          <p:cNvSpPr txBox="1"/>
+          <p:nvPr/>
+        </p:nvSpPr>
+        <p:spPr>
+          <a:xfrm>
+            <a:off x="548640" y="2148840"/>
+            <a:ext cx="5349240" cy="411480"/>
+          </a:xfrm>
+          <a:prstGeom prst="rect">
+            <a:avLst/>
+          </a:prstGeom>
+          <a:noFill/>
+          <a:ln/>
+        </p:spPr>
+        <p:txBody>
+          <a:bodyPr wrap="square" lIns="0" tIns="0" rIns="0" bIns="0" rtlCol="0" anchor="ctr"/>
+          <a:lstStyle/>
+          <a:p>
+            <a:pPr indent="0" marL="0">
+              <a:buNone/>
+            </a:pPr>
+            <a:r>
+              <a:rPr lang="en-US" sz="1800" dirty="0">
+                <a:solidFill>
+                  <a:srgbClr val="5C6F7B"/>
+                </a:solidFill>
+              </a:rPr>
+              <a:t>un ordine: metti questo valore in questa etichetta</a:t>
+            </a:r>
+            <a:endParaRPr lang="en-US" sz="1800" dirty="0"/>
+          </a:p>
+        </p:txBody>
+      </p:sp>
+      <p:sp>
+        <p:nvSpPr>
+          <p:cNvPr id="5" name="card-code"/>
+          <p:cNvSpPr/>
+          <p:nvPr/>
+        </p:nvSpPr>
+        <p:spPr>
+          <a:xfrm>
+            <a:off x="548640" y="2697480"/>
+            <a:ext cx="5349240" cy="1097280"/>
+          </a:xfrm>
+          <a:prstGeom prst="roundRect">
+            <a:avLst>
+              <a:gd name="adj" fmla="val 10000"/>
+            </a:avLst>
+          </a:prstGeom>
+          <a:solidFill>
+            <a:srgbClr val="1F2A30"/>
+          </a:solidFill>
+          <a:ln/>
+        </p:spPr>
+      </p:sp>
+      <p:sp>
+        <p:nvSpPr>
+          <p:cNvPr id="6" name="Text 4"/>
+          <p:cNvSpPr txBox="1"/>
+          <p:nvPr/>
+        </p:nvSpPr>
+        <p:spPr>
+          <a:xfrm>
+            <a:off x="777240" y="2834640"/>
+            <a:ext cx="1828800" cy="274320"/>
+          </a:xfrm>
+          <a:prstGeom prst="rect">
+            <a:avLst/>
+          </a:prstGeom>
+          <a:noFill/>
+          <a:ln/>
+        </p:spPr>
+        <p:txBody>
+          <a:bodyPr wrap="square" lIns="0" tIns="0" rIns="0" bIns="0" rtlCol="0" anchor="ctr"/>
+          <a:lstStyle/>
+          <a:p>
+            <a:pPr indent="0" marL="0">
+              <a:buNone/>
+            </a:pPr>
+            <a:r>
+              <a:rPr lang="en-US" sz="1100" b="1" spc="200" kern="0" dirty="0">
+                <a:solidFill>
+                  <a:srgbClr val="E09F3E"/>
+                </a:solidFill>
+              </a:rPr>
+              <a:t>PYTHON</a:t>
+            </a:r>
+            <a:endParaRPr lang="en-US" sz="1100" dirty="0"/>
+          </a:p>
+        </p:txBody>
+      </p:sp>
+      <p:sp>
+        <p:nvSpPr>
+          <p:cNvPr id="7" name="Text 5"/>
+          <p:cNvSpPr txBox="1"/>
+          <p:nvPr/>
+        </p:nvSpPr>
+        <p:spPr>
+          <a:xfrm>
+            <a:off x="777240" y="3154680"/>
+            <a:ext cx="4892040" cy="502920"/>
+          </a:xfrm>
+          <a:prstGeom prst="rect">
+            <a:avLst/>
+          </a:prstGeom>
+          <a:noFill/>
+          <a:ln/>
+        </p:spPr>
+        <p:txBody>
+          <a:bodyPr wrap="square" lIns="0" tIns="0" rIns="0" bIns="0" rtlCol="0" anchor="t"/>
+          <a:lstStyle/>
+          <a:p>
+            <a:pPr indent="0" marL="0">
+              <a:buNone/>
+            </a:pPr>
+            <a:r>
+              <a:rPr lang="en-US" sz="2200" dirty="0">
+                <a:solidFill>
+                  <a:srgbClr val="FFFFFF"/>
+                </a:solidFill>
+                <a:latin typeface="Courier New" pitchFamily="34" charset="0"/>
+                <a:ea typeface="Courier New" pitchFamily="34" charset="-122"/>
+                <a:cs typeface="Courier New" pitchFamily="34" charset="-120"/>
+              </a:rPr>
+              <a:t>montante = 6400</a:t>
+            </a:r>
+            <a:endParaRPr lang="en-US" sz="2200" dirty="0"/>
+          </a:p>
+        </p:txBody>
+      </p:sp>
+      <p:sp>
+        <p:nvSpPr>
+          <p:cNvPr id="8" name="card-out"/>
+          <p:cNvSpPr/>
+          <p:nvPr/>
+        </p:nvSpPr>
+        <p:spPr>
+          <a:xfrm>
+            <a:off x="548640" y="3977640"/>
+            <a:ext cx="5349240" cy="1097280"/>
+          </a:xfrm>
+          <a:prstGeom prst="roundRect">
+            <a:avLst>
+              <a:gd name="adj" fmla="val 10000"/>
+            </a:avLst>
+          </a:prstGeom>
+          <a:solidFill>
+            <a:srgbClr val="EEF3F4"/>
+          </a:solidFill>
+          <a:ln/>
+        </p:spPr>
+      </p:sp>
+      <p:sp>
+        <p:nvSpPr>
+          <p:cNvPr id="9" name="Text 7"/>
+          <p:cNvSpPr txBox="1"/>
+          <p:nvPr/>
+        </p:nvSpPr>
+        <p:spPr>
+          <a:xfrm>
+            <a:off x="777240" y="4114800"/>
+            <a:ext cx="1828800" cy="274320"/>
+          </a:xfrm>
+          <a:prstGeom prst="rect">
+            <a:avLst/>
+          </a:prstGeom>
+          <a:noFill/>
+          <a:ln/>
+        </p:spPr>
+        <p:txBody>
+          <a:bodyPr wrap="square" lIns="0" tIns="0" rIns="0" bIns="0" rtlCol="0" anchor="ctr"/>
+          <a:lstStyle/>
+          <a:p>
+            <a:pPr indent="0" marL="0">
+              <a:buNone/>
+            </a:pPr>
+            <a:r>
+              <a:rPr lang="en-US" sz="1100" b="1" spc="200" kern="0" dirty="0">
+                <a:solidFill>
+                  <a:srgbClr val="5C6F7B"/>
+                </a:solidFill>
+              </a:rPr>
+              <a:t>OUTPUT</a:t>
+            </a:r>
+            <a:endParaRPr lang="en-US" sz="1100" dirty="0"/>
+          </a:p>
+        </p:txBody>
+      </p:sp>
+      <p:sp>
+        <p:nvSpPr>
+          <p:cNvPr id="10" name="Text 8"/>
+          <p:cNvSpPr txBox="1"/>
+          <p:nvPr/>
+        </p:nvSpPr>
+        <p:spPr>
+          <a:xfrm>
+            <a:off x="777240" y="4434840"/>
+            <a:ext cx="4892040" cy="502920"/>
+          </a:xfrm>
+          <a:prstGeom prst="rect">
+            <a:avLst/>
+          </a:prstGeom>
+          <a:noFill/>
+          <a:ln/>
+        </p:spPr>
+        <p:txBody>
+          <a:bodyPr wrap="square" lIns="0" tIns="0" rIns="0" bIns="0" rtlCol="0" anchor="t"/>
+          <a:lstStyle/>
+          <a:p>
+            <a:pPr indent="0" marL="0">
+              <a:buNone/>
+            </a:pPr>
+            <a:r>
+              <a:rPr lang="en-US" sz="1600" dirty="0">
+                <a:solidFill>
+                  <a:srgbClr val="1F2A30"/>
+                </a:solidFill>
+                <a:latin typeface="Courier New" pitchFamily="34" charset="0"/>
+                <a:ea typeface="Courier New" pitchFamily="34" charset="-122"/>
+                <a:cs typeface="Courier New" pitchFamily="34" charset="-120"/>
+              </a:rPr>
+              <a:t>(nessun output: montante ora vale 6400)</a:t>
+            </a:r>
+            <a:endParaRPr lang="en-US" sz="1600" dirty="0"/>
+          </a:p>
+        </p:txBody>
+      </p:sp>
+      <p:sp>
+        <p:nvSpPr>
+          <p:cNvPr id="11" name="Text 9"/>
+          <p:cNvSpPr txBox="1"/>
+          <p:nvPr/>
+        </p:nvSpPr>
+        <p:spPr>
+          <a:xfrm>
+            <a:off x="6263640" y="1600200"/>
+            <a:ext cx="5349240" cy="548640"/>
+          </a:xfrm>
+          <a:prstGeom prst="rect">
+            <a:avLst/>
+          </a:prstGeom>
+          <a:noFill/>
+          <a:ln/>
+        </p:spPr>
+        <p:txBody>
+          <a:bodyPr wrap="square" lIns="0" tIns="0" rIns="0" bIns="0" rtlCol="0" anchor="ctr"/>
+          <a:lstStyle/>
+          <a:p>
+            <a:pPr indent="0" marL="0">
+              <a:buNone/>
+            </a:pPr>
+            <a:r>
+              <a:rPr lang="en-US" sz="2800" b="1" dirty="0">
+                <a:solidFill>
+                  <a:srgbClr val="8F5308"/>
+                </a:solidFill>
+                <a:latin typeface="Courier New" pitchFamily="34" charset="0"/>
+                <a:ea typeface="Courier New" pitchFamily="34" charset="-122"/>
+                <a:cs typeface="Courier New" pitchFamily="34" charset="-120"/>
+              </a:rPr>
+              <a:t>==</a:t>
+            </a:r>
+            <a:pPr indent="0" marL="0">
+              <a:buNone/>
+            </a:pPr>
+            <a:r>
+              <a:rPr lang="en-US" sz="2800" b="1" dirty="0">
+                <a:solidFill>
+                  <a:srgbClr val="0F4C5C"/>
+                </a:solidFill>
+              </a:rPr>
+              <a:t>  confronto</a:t>
+            </a:r>
+            <a:endParaRPr lang="en-US" sz="2800" dirty="0"/>
+          </a:p>
+        </p:txBody>
+      </p:sp>
+      <p:sp>
+        <p:nvSpPr>
+          <p:cNvPr id="12" name="Text 10"/>
+          <p:cNvSpPr txBox="1"/>
+          <p:nvPr/>
+        </p:nvSpPr>
+        <p:spPr>
+          <a:xfrm>
+            <a:off x="6263640" y="2148840"/>
+            <a:ext cx="5349240" cy="411480"/>
+          </a:xfrm>
+          <a:prstGeom prst="rect">
+            <a:avLst/>
+          </a:prstGeom>
+          <a:noFill/>
+          <a:ln/>
+        </p:spPr>
+        <p:txBody>
+          <a:bodyPr wrap="square" lIns="0" tIns="0" rIns="0" bIns="0" rtlCol="0" anchor="ctr"/>
+          <a:lstStyle/>
+          <a:p>
+            <a:pPr indent="0" marL="0">
+              <a:buNone/>
+            </a:pPr>
+            <a:r>
+              <a:rPr lang="en-US" sz="1800" dirty="0">
+                <a:solidFill>
+                  <a:srgbClr val="5C6F7B"/>
+                </a:solidFill>
+              </a:rPr>
+              <a:t>una domanda: queste due cose sono uguali?</a:t>
+            </a:r>
+            <a:endParaRPr lang="en-US" sz="1800" dirty="0"/>
+          </a:p>
+        </p:txBody>
+      </p:sp>
+      <p:sp>
+        <p:nvSpPr>
+          <p:cNvPr id="13" name="card-code"/>
+          <p:cNvSpPr/>
+          <p:nvPr/>
+        </p:nvSpPr>
+        <p:spPr>
+          <a:xfrm>
+            <a:off x="6263640" y="2697480"/>
+            <a:ext cx="5349240" cy="1097280"/>
+          </a:xfrm>
+          <a:prstGeom prst="roundRect">
+            <a:avLst>
+              <a:gd name="adj" fmla="val 10000"/>
+            </a:avLst>
+          </a:prstGeom>
+          <a:solidFill>
+            <a:srgbClr val="1F2A30"/>
+          </a:solidFill>
+          <a:ln/>
+        </p:spPr>
+      </p:sp>
+      <p:sp>
+        <p:nvSpPr>
+          <p:cNvPr id="14" name="Text 12"/>
+          <p:cNvSpPr txBox="1"/>
+          <p:nvPr/>
+        </p:nvSpPr>
+        <p:spPr>
+          <a:xfrm>
+            <a:off x="6492240" y="2834640"/>
+            <a:ext cx="1828800" cy="274320"/>
+          </a:xfrm>
+          <a:prstGeom prst="rect">
+            <a:avLst/>
+          </a:prstGeom>
+          <a:noFill/>
+          <a:ln/>
+        </p:spPr>
+        <p:txBody>
+          <a:bodyPr wrap="square" lIns="0" tIns="0" rIns="0" bIns="0" rtlCol="0" anchor="ctr"/>
+          <a:lstStyle/>
+          <a:p>
+            <a:pPr indent="0" marL="0">
+              <a:buNone/>
+            </a:pPr>
+            <a:r>
+              <a:rPr lang="en-US" sz="1100" b="1" spc="200" kern="0" dirty="0">
+                <a:solidFill>
+                  <a:srgbClr val="E09F3E"/>
+                </a:solidFill>
+              </a:rPr>
+              <a:t>PYTHON</a:t>
+            </a:r>
+            <a:endParaRPr lang="en-US" sz="1100" dirty="0"/>
+          </a:p>
+        </p:txBody>
+      </p:sp>
+      <p:sp>
+        <p:nvSpPr>
+          <p:cNvPr id="15" name="Text 13"/>
+          <p:cNvSpPr txBox="1"/>
+          <p:nvPr/>
+        </p:nvSpPr>
+        <p:spPr>
+          <a:xfrm>
+            <a:off x="6492240" y="3154680"/>
+            <a:ext cx="4892040" cy="502920"/>
+          </a:xfrm>
+          <a:prstGeom prst="rect">
+            <a:avLst/>
+          </a:prstGeom>
+          <a:noFill/>
+          <a:ln/>
+        </p:spPr>
+        <p:txBody>
+          <a:bodyPr wrap="square" lIns="0" tIns="0" rIns="0" bIns="0" rtlCol="0" anchor="t"/>
+          <a:lstStyle/>
+          <a:p>
+            <a:pPr indent="0" marL="0">
+              <a:buNone/>
+            </a:pPr>
+            <a:r>
+              <a:rPr lang="en-US" sz="2200" dirty="0">
+                <a:solidFill>
+                  <a:srgbClr val="FFFFFF"/>
+                </a:solidFill>
+                <a:latin typeface="Courier New" pitchFamily="34" charset="0"/>
+                <a:ea typeface="Courier New" pitchFamily="34" charset="-122"/>
+                <a:cs typeface="Courier New" pitchFamily="34" charset="-120"/>
+              </a:rPr>
+              <a:t>montante == 6400</a:t>
+            </a:r>
+            <a:endParaRPr lang="en-US" sz="2200" dirty="0"/>
+          </a:p>
+        </p:txBody>
+      </p:sp>
+      <p:sp>
+        <p:nvSpPr>
+          <p:cNvPr id="16" name="card-out"/>
+          <p:cNvSpPr/>
+          <p:nvPr/>
+        </p:nvSpPr>
+        <p:spPr>
+          <a:xfrm>
+            <a:off x="6263640" y="3977640"/>
+            <a:ext cx="5349240" cy="1097280"/>
+          </a:xfrm>
+          <a:prstGeom prst="roundRect">
+            <a:avLst>
+              <a:gd name="adj" fmla="val 10000"/>
+            </a:avLst>
+          </a:prstGeom>
+          <a:solidFill>
+            <a:srgbClr val="EEF3F4"/>
+          </a:solidFill>
+          <a:ln/>
+        </p:spPr>
+      </p:sp>
+      <p:sp>
+        <p:nvSpPr>
+          <p:cNvPr id="17" name="Text 15"/>
+          <p:cNvSpPr txBox="1"/>
+          <p:nvPr/>
+        </p:nvSpPr>
+        <p:spPr>
+          <a:xfrm>
+            <a:off x="6492240" y="4114800"/>
+            <a:ext cx="1828800" cy="274320"/>
+          </a:xfrm>
+          <a:prstGeom prst="rect">
+            <a:avLst/>
+          </a:prstGeom>
+          <a:noFill/>
+          <a:ln/>
+        </p:spPr>
+        <p:txBody>
+          <a:bodyPr wrap="square" lIns="0" tIns="0" rIns="0" bIns="0" rtlCol="0" anchor="ctr"/>
+          <a:lstStyle/>
+          <a:p>
+            <a:pPr indent="0" marL="0">
+              <a:buNone/>
+            </a:pPr>
+            <a:r>
+              <a:rPr lang="en-US" sz="1100" b="1" spc="200" kern="0" dirty="0">
+                <a:solidFill>
+                  <a:srgbClr val="5C6F7B"/>
+                </a:solidFill>
+              </a:rPr>
+              <a:t>OUTPUT</a:t>
+            </a:r>
+            <a:endParaRPr lang="en-US" sz="1100" dirty="0"/>
+          </a:p>
+        </p:txBody>
+      </p:sp>
+      <p:sp>
+        <p:nvSpPr>
+          <p:cNvPr id="18" name="Text 16"/>
+          <p:cNvSpPr txBox="1"/>
+          <p:nvPr/>
+        </p:nvSpPr>
+        <p:spPr>
+          <a:xfrm>
+            <a:off x="6492240" y="4434840"/>
+            <a:ext cx="4892040" cy="502920"/>
+          </a:xfrm>
+          <a:prstGeom prst="rect">
+            <a:avLst/>
+          </a:prstGeom>
+          <a:noFill/>
+          <a:ln/>
+        </p:spPr>
+        <p:txBody>
+          <a:bodyPr wrap="square" lIns="0" tIns="0" rIns="0" bIns="0" rtlCol="0" anchor="t"/>
+          <a:lstStyle/>
+          <a:p>
+            <a:pPr indent="0" marL="0">
+              <a:buNone/>
+            </a:pPr>
+            <a:r>
+              <a:rPr lang="en-US" sz="2200" dirty="0">
+                <a:solidFill>
+                  <a:srgbClr val="1F2A30"/>
+                </a:solidFill>
+                <a:latin typeface="Courier New" pitchFamily="34" charset="0"/>
+                <a:ea typeface="Courier New" pitchFamily="34" charset="-122"/>
+                <a:cs typeface="Courier New" pitchFamily="34" charset="-120"/>
+              </a:rPr>
+              <a:t>False</a:t>
+            </a:r>
+            <a:endParaRPr lang="en-US" sz="2200" dirty="0"/>
+          </a:p>
+        </p:txBody>
+      </p:sp>
+      <p:sp>
+        <p:nvSpPr>
+          <p:cNvPr id="19" name="Text 17"/>
+          <p:cNvSpPr txBox="1"/>
+          <p:nvPr/>
+        </p:nvSpPr>
+        <p:spPr>
+          <a:xfrm>
+            <a:off x="548640" y="5349240"/>
+            <a:ext cx="11064240" cy="731520"/>
+          </a:xfrm>
+          <a:prstGeom prst="rect">
+            <a:avLst/>
+          </a:prstGeom>
+          <a:noFill/>
+          <a:ln/>
+        </p:spPr>
+        <p:txBody>
+          <a:bodyPr wrap="square" lIns="0" tIns="0" rIns="0" bIns="0" rtlCol="0" anchor="t"/>
+          <a:lstStyle/>
+          <a:p>
+            <a:pPr indent="0" marL="0">
+              <a:buNone/>
+            </a:pPr>
+            <a:r>
+              <a:rPr lang="en-US" sz="1700" b="1" dirty="0">
+                <a:solidFill>
+                  <a:srgbClr val="1F2A30"/>
+                </a:solidFill>
+              </a:rPr>
+              <a:t>Altri confronti: </a:t>
+            </a:r>
+            <a:pPr indent="0" marL="0">
+              <a:buNone/>
+            </a:pPr>
+            <a:r>
+              <a:rPr lang="en-US" sz="1700" b="1" dirty="0">
+                <a:solidFill>
+                  <a:srgbClr val="0F4C5C"/>
+                </a:solidFill>
+                <a:latin typeface="Courier New" pitchFamily="34" charset="0"/>
+                <a:ea typeface="Courier New" pitchFamily="34" charset="-122"/>
+                <a:cs typeface="Courier New" pitchFamily="34" charset="-120"/>
+              </a:rPr>
+              <a:t>&gt;  &lt;  &gt;=  &lt;=  !=</a:t>
+            </a:r>
+            <a:pPr indent="0" marL="0">
+              <a:buNone/>
+            </a:pPr>
+            <a:r>
+              <a:rPr lang="en-US" sz="1700" dirty="0">
+                <a:solidFill>
+                  <a:srgbClr val="1F2A30"/>
+                </a:solidFill>
+              </a:rPr>
+              <a:t>  — rispondono sempre True o False (tipo bool). Scambiare = con == non dà errore: cambia il valore in silenzio.</a:t>
+            </a:r>
+            <a:endParaRPr lang="en-US" sz="1700" dirty="0"/>
+          </a:p>
+        </p:txBody>
+      </p:sp>
+      <p:sp>
+        <p:nvSpPr>
+          <p:cNvPr id="25" name="Slide Number Placeholder 0"/>
+          <p:cNvSpPr>
+            <a:spLocks noGrp="1"/>
+          </p:cNvSpPr>
+          <p:nvPr>
+            <p:ph type="sldNum" sz="quarter" idx="4294967295"/>
+          </p:nvPr>
+        </p:nvSpPr>
+        <p:spPr>
+          <a:xfrm>
+            <a:off x="11155680" y="6400800"/>
+            <a:ext cx="457200" cy="274320"/>
+          </a:xfrm>
+          <a:prstGeom prst="rect">
+            <a:avLst/>
+          </a:prstGeom>
+          <a:extLst>
+            <a:ext uri="{C572A759-6A51-4108-AA02-DFA0A04FC94B}">
+              <ma14:wrappingTextBoxFlag xmlns:ma14="http://schemas.microsoft.com/office/mac/drawingml/2011/main" val="0"/>
+            </a:ext>
+          </a:extLst>
+        </p:spPr>
+        <p:txBody>
+          <a:bodyPr/>
+          <a:lstStyle>
+            <a:lvl1pPr>
+              <a:defRPr sz="1000">
+                <a:solidFill>
+                  <a:srgbClr val="5C6F7B"/>
+                </a:solidFill>
+              </a:defRPr>
+            </a:lvl1pPr>
+          </a:lstStyle>
+          <a:p>
+            <a:pPr algn="r"/>
+            <a:fld id="{F7021451-1387-4CA6-816F-3879F97B5CBC}" type="slidenum">
+              <a:rPr b="0" lang="en-US"/>
+              <a:t>11</a:t>
+            </a:fld>
+            <a:endParaRPr lang="en-US"/>
+          </a:p>
+        </p:txBody>
+      </p:sp>
+    </p:spTree>
+  </p:cSld>
+  <p:clrMapOvr>
+    <a:masterClrMapping/>
+  </p:clrMapOvr>
+</p:sld>
+</file>
+
+<file path=ppt/slides/slide12.xml><?xml version="1.0" encoding="utf-8"?>
+<p:sld xmlns:a="http://schemas.openxmlformats.org/drawingml/2006/main" xmlns:r="http://schemas.openxmlformats.org/officeDocument/2006/relationships" xmlns:p="http://schemas.openxmlformats.org/presentationml/2006/main">
+  <p:cSld name="Slide 12">
+    <p:spTree>
+      <p:nvGrpSpPr>
+        <p:cNvPr id="1" name=""/>
+        <p:cNvGrpSpPr/>
+        <p:nvPr/>
+      </p:nvGrpSpPr>
+      <p:grpSpPr>
+        <a:xfrm>
+          <a:off x="0" y="0"/>
+          <a:ext cx="0" cy="0"/>
+          <a:chOff x="0" y="0"/>
+          <a:chExt cx="0" cy="0"/>
+        </a:xfrm>
+      </p:grpSpPr>
+      <p:sp>
+        <p:nvSpPr>
+          <p:cNvPr id="2" name="Text 0"/>
+          <p:cNvSpPr/>
+          <p:nvPr>
+            <p:ph idx="100" type="title" hasCustomPrompt="1"/>
+          </p:nvPr>
+        </p:nvSpPr>
+        <p:spPr>
+          <a:xfrm>
+            <a:off x="548640" y="365760"/>
+            <a:ext cx="11064240" cy="822960"/>
+          </a:xfrm>
+          <a:prstGeom prst="rect">
+            <a:avLst/>
+          </a:prstGeom>
+          <a:noFill/>
+          <a:ln/>
+        </p:spPr>
+        <p:txBody>
+          <a:bodyPr wrap="square" lIns="0" tIns="0" rIns="0" bIns="0" rtlCol="0" anchor="ctr"/>
+          <a:lstStyle/>
+          <a:p>
+            <a:pPr algn="l" indent="0" marL="0">
+              <a:buNone/>
+            </a:pPr>
+            <a:r>
+              <a:rPr lang="en-US" sz="3600" b="1" dirty="0">
+                <a:solidFill>
+                  <a:srgbClr val="0F4C5C"/>
+                </a:solidFill>
+              </a:rPr>
               <a:t>Tipi di dato</a:t>
             </a:r>
             <a:endParaRPr lang="en-US" sz="3600" dirty="0"/>
@@ -3146,7 +3965,7 @@
       </p:sp>
       <p:graphicFrame>
         <p:nvGraphicFramePr>
-          <p:cNvPr id="12" name="Table 0"/>
+          <p:cNvPr id="13" name="Table 0"/>
           <p:cNvGraphicFramePr>
             <a:graphicFrameLocks noGrp="1"/>
           </p:cNvGraphicFramePr>
@@ -4033,411 +4852,6 @@
             <a:pPr algn="r"/>
             <a:fld id="{F7021451-1387-4CA6-816F-3879F97B5CBC}" type="slidenum">
               <a:rPr b="0" lang="en-US"/>
-              <a:t>11</a:t>
-            </a:fld>
-            <a:endParaRPr lang="en-US"/>
-          </a:p>
-        </p:txBody>
-      </p:sp>
-    </p:spTree>
-  </p:cSld>
-  <p:clrMapOvr>
-    <a:masterClrMapping/>
-  </p:clrMapOvr>
-</p:sld>
-</file>
-
-<file path=ppt/slides/slide12.xml><?xml version="1.0" encoding="utf-8"?>
-<p:sld xmlns:a="http://schemas.openxmlformats.org/drawingml/2006/main" xmlns:r="http://schemas.openxmlformats.org/officeDocument/2006/relationships" xmlns:p="http://schemas.openxmlformats.org/presentationml/2006/main">
-  <p:cSld name="Slide 12">
-    <p:spTree>
-      <p:nvGrpSpPr>
-        <p:cNvPr id="1" name=""/>
-        <p:cNvGrpSpPr/>
-        <p:nvPr/>
-      </p:nvGrpSpPr>
-      <p:grpSpPr>
-        <a:xfrm>
-          <a:off x="0" y="0"/>
-          <a:ext cx="0" cy="0"/>
-          <a:chOff x="0" y="0"/>
-          <a:chExt cx="0" cy="0"/>
-        </a:xfrm>
-      </p:grpSpPr>
-      <p:sp>
-        <p:nvSpPr>
-          <p:cNvPr id="2" name="Text 0"/>
-          <p:cNvSpPr/>
-          <p:nvPr>
-            <p:ph idx="100" type="title" hasCustomPrompt="1"/>
-          </p:nvPr>
-        </p:nvSpPr>
-        <p:spPr>
-          <a:xfrm>
-            <a:off x="548640" y="365760"/>
-            <a:ext cx="11064240" cy="822960"/>
-          </a:xfrm>
-          <a:prstGeom prst="rect">
-            <a:avLst/>
-          </a:prstGeom>
-          <a:noFill/>
-          <a:ln/>
-        </p:spPr>
-        <p:txBody>
-          <a:bodyPr wrap="square" lIns="0" tIns="0" rIns="0" bIns="0" rtlCol="0" anchor="ctr"/>
-          <a:lstStyle/>
-          <a:p>
-            <a:pPr algn="l" indent="0" marL="0">
-              <a:buNone/>
-            </a:pPr>
-            <a:r>
-              <a:rPr lang="en-US" sz="3600" b="1" dirty="0">
-                <a:solidFill>
-                  <a:srgbClr val="0F4C5C"/>
-                </a:solidFill>
-              </a:rPr>
-              <a:t>La trappola del passo 6</a:t>
-            </a:r>
-            <a:endParaRPr lang="en-US" sz="3600" dirty="0"/>
-          </a:p>
-        </p:txBody>
-      </p:sp>
-      <p:sp>
-        <p:nvSpPr>
-          <p:cNvPr id="3" name="card-code"/>
-          <p:cNvSpPr/>
-          <p:nvPr/>
-        </p:nvSpPr>
-        <p:spPr>
-          <a:xfrm>
-            <a:off x="548640" y="1737360"/>
-            <a:ext cx="5577840" cy="1645920"/>
-          </a:xfrm>
-          <a:prstGeom prst="roundRect">
-            <a:avLst>
-              <a:gd name="adj" fmla="val 6667"/>
-            </a:avLst>
-          </a:prstGeom>
-          <a:solidFill>
-            <a:srgbClr val="1F2A30"/>
-          </a:solidFill>
-          <a:ln/>
-        </p:spPr>
-      </p:sp>
-      <p:sp>
-        <p:nvSpPr>
-          <p:cNvPr id="4" name="Text 2"/>
-          <p:cNvSpPr txBox="1"/>
-          <p:nvPr/>
-        </p:nvSpPr>
-        <p:spPr>
-          <a:xfrm>
-            <a:off x="777240" y="1874520"/>
-            <a:ext cx="1828800" cy="274320"/>
-          </a:xfrm>
-          <a:prstGeom prst="rect">
-            <a:avLst/>
-          </a:prstGeom>
-          <a:noFill/>
-          <a:ln/>
-        </p:spPr>
-        <p:txBody>
-          <a:bodyPr wrap="square" lIns="0" tIns="0" rIns="0" bIns="0" rtlCol="0" anchor="ctr"/>
-          <a:lstStyle/>
-          <a:p>
-            <a:pPr indent="0" marL="0">
-              <a:buNone/>
-            </a:pPr>
-            <a:r>
-              <a:rPr lang="en-US" sz="1100" b="1" spc="200" kern="0" dirty="0">
-                <a:solidFill>
-                  <a:srgbClr val="E09F3E"/>
-                </a:solidFill>
-              </a:rPr>
-              <a:t>PYTHON</a:t>
-            </a:r>
-            <a:endParaRPr lang="en-US" sz="1100" dirty="0"/>
-          </a:p>
-        </p:txBody>
-      </p:sp>
-      <p:sp>
-        <p:nvSpPr>
-          <p:cNvPr id="5" name="Text 3"/>
-          <p:cNvSpPr txBox="1"/>
-          <p:nvPr/>
-        </p:nvSpPr>
-        <p:spPr>
-          <a:xfrm>
-            <a:off x="777240" y="2194560"/>
-            <a:ext cx="5120640" cy="1051560"/>
-          </a:xfrm>
-          <a:prstGeom prst="rect">
-            <a:avLst/>
-          </a:prstGeom>
-          <a:noFill/>
-          <a:ln/>
-        </p:spPr>
-        <p:txBody>
-          <a:bodyPr wrap="square" lIns="0" tIns="0" rIns="0" bIns="0" rtlCol="0" anchor="t"/>
-          <a:lstStyle/>
-          <a:p>
-            <a:pPr indent="0" marL="0">
-              <a:buNone/>
-            </a:pPr>
-            <a:r>
-              <a:rPr lang="en-US" sz="2000" dirty="0">
-                <a:solidFill>
-                  <a:srgbClr val="FFFFFF"/>
-                </a:solidFill>
-                <a:latin typeface="Courier New" pitchFamily="34" charset="0"/>
-                <a:ea typeface="Courier New" pitchFamily="34" charset="-122"/>
-                <a:cs typeface="Courier New" pitchFamily="34" charset="-120"/>
-              </a:rPr>
-              <a:t>capitale_testo = "5000"</a:t>
-            </a:r>
-            <a:endParaRPr lang="en-US" sz="2000" dirty="0"/>
-          </a:p>
-          <a:p>
-            <a:pPr indent="0" marL="0">
-              <a:buNone/>
-            </a:pPr>
-            <a:r>
-              <a:rPr lang="en-US" sz="2000" dirty="0">
-                <a:solidFill>
-                  <a:srgbClr val="FFFFFF"/>
-                </a:solidFill>
-                <a:latin typeface="Courier New" pitchFamily="34" charset="0"/>
-                <a:ea typeface="Courier New" pitchFamily="34" charset="-122"/>
-                <a:cs typeface="Courier New" pitchFamily="34" charset="-120"/>
-              </a:rPr>
-              <a:t>print(capitale_testo * 2)</a:t>
-            </a:r>
-            <a:endParaRPr lang="en-US" sz="2000" dirty="0"/>
-          </a:p>
-        </p:txBody>
-      </p:sp>
-      <p:sp>
-        <p:nvSpPr>
-          <p:cNvPr id="6" name="card-out"/>
-          <p:cNvSpPr/>
-          <p:nvPr/>
-        </p:nvSpPr>
-        <p:spPr>
-          <a:xfrm>
-            <a:off x="548640" y="3657600"/>
-            <a:ext cx="5577840" cy="1280160"/>
-          </a:xfrm>
-          <a:prstGeom prst="roundRect">
-            <a:avLst>
-              <a:gd name="adj" fmla="val 8571"/>
-            </a:avLst>
-          </a:prstGeom>
-          <a:solidFill>
-            <a:srgbClr val="EEF3F4"/>
-          </a:solidFill>
-          <a:ln/>
-        </p:spPr>
-      </p:sp>
-      <p:sp>
-        <p:nvSpPr>
-          <p:cNvPr id="7" name="Text 5"/>
-          <p:cNvSpPr txBox="1"/>
-          <p:nvPr/>
-        </p:nvSpPr>
-        <p:spPr>
-          <a:xfrm>
-            <a:off x="777240" y="3794760"/>
-            <a:ext cx="1828800" cy="274320"/>
-          </a:xfrm>
-          <a:prstGeom prst="rect">
-            <a:avLst/>
-          </a:prstGeom>
-          <a:noFill/>
-          <a:ln/>
-        </p:spPr>
-        <p:txBody>
-          <a:bodyPr wrap="square" lIns="0" tIns="0" rIns="0" bIns="0" rtlCol="0" anchor="ctr"/>
-          <a:lstStyle/>
-          <a:p>
-            <a:pPr indent="0" marL="0">
-              <a:buNone/>
-            </a:pPr>
-            <a:r>
-              <a:rPr lang="en-US" sz="1100" b="1" spc="200" kern="0" dirty="0">
-                <a:solidFill>
-                  <a:srgbClr val="5C6F7B"/>
-                </a:solidFill>
-              </a:rPr>
-              <a:t>OUTPUT</a:t>
-            </a:r>
-            <a:endParaRPr lang="en-US" sz="1100" dirty="0"/>
-          </a:p>
-        </p:txBody>
-      </p:sp>
-      <p:sp>
-        <p:nvSpPr>
-          <p:cNvPr id="8" name="Text 6"/>
-          <p:cNvSpPr txBox="1"/>
-          <p:nvPr/>
-        </p:nvSpPr>
-        <p:spPr>
-          <a:xfrm>
-            <a:off x="777240" y="4114800"/>
-            <a:ext cx="5120640" cy="685800"/>
-          </a:xfrm>
-          <a:prstGeom prst="rect">
-            <a:avLst/>
-          </a:prstGeom>
-          <a:noFill/>
-          <a:ln/>
-        </p:spPr>
-        <p:txBody>
-          <a:bodyPr wrap="square" lIns="0" tIns="0" rIns="0" bIns="0" rtlCol="0" anchor="t"/>
-          <a:lstStyle/>
-          <a:p>
-            <a:pPr indent="0" marL="0">
-              <a:buNone/>
-            </a:pPr>
-            <a:r>
-              <a:rPr lang="en-US" sz="2400" dirty="0">
-                <a:solidFill>
-                  <a:srgbClr val="1F2A30"/>
-                </a:solidFill>
-                <a:latin typeface="Courier New" pitchFamily="34" charset="0"/>
-                <a:ea typeface="Courier New" pitchFamily="34" charset="-122"/>
-                <a:cs typeface="Courier New" pitchFamily="34" charset="-120"/>
-              </a:rPr>
-              <a:t>50005000</a:t>
-            </a:r>
-            <a:endParaRPr lang="en-US" sz="2400" dirty="0"/>
-          </a:p>
-        </p:txBody>
-      </p:sp>
-      <p:sp>
-        <p:nvSpPr>
-          <p:cNvPr id="9" name="Text 7"/>
-          <p:cNvSpPr txBox="1"/>
-          <p:nvPr/>
-        </p:nvSpPr>
-        <p:spPr>
-          <a:xfrm>
-            <a:off x="6675120" y="1737360"/>
-            <a:ext cx="4937760" cy="1645920"/>
-          </a:xfrm>
-          <a:prstGeom prst="rect">
-            <a:avLst/>
-          </a:prstGeom>
-          <a:noFill/>
-          <a:ln/>
-        </p:spPr>
-        <p:txBody>
-          <a:bodyPr wrap="square" lIns="0" tIns="0" rIns="0" bIns="0" rtlCol="0" anchor="t"/>
-          <a:lstStyle/>
-          <a:p>
-            <a:pPr indent="0" marL="0">
-              <a:buNone/>
-            </a:pPr>
-            <a:r>
-              <a:rPr lang="en-US" sz="3200" b="1" dirty="0">
-                <a:solidFill>
-                  <a:srgbClr val="9E2A2B"/>
-                </a:solidFill>
-              </a:rPr>
-              <a:t>Nessun errore.</a:t>
-            </a:r>
-            <a:endParaRPr lang="en-US" sz="3200" dirty="0"/>
-          </a:p>
-          <a:p>
-            <a:pPr indent="0" marL="0">
-              <a:buNone/>
-            </a:pPr>
-            <a:r>
-              <a:rPr lang="en-US" sz="3200" b="1" dirty="0">
-                <a:solidFill>
-                  <a:srgbClr val="9E2A2B"/>
-                </a:solidFill>
-              </a:rPr>
-              <a:t>Risultato sbagliato.</a:t>
-            </a:r>
-            <a:endParaRPr lang="en-US" sz="3200" dirty="0"/>
-          </a:p>
-        </p:txBody>
-      </p:sp>
-      <p:sp>
-        <p:nvSpPr>
-          <p:cNvPr id="10" name="Text 8"/>
-          <p:cNvSpPr txBox="1"/>
-          <p:nvPr/>
-        </p:nvSpPr>
-        <p:spPr>
-          <a:xfrm>
-            <a:off x="6675120" y="3566160"/>
-            <a:ext cx="4937760" cy="1463040"/>
-          </a:xfrm>
-          <a:prstGeom prst="rect">
-            <a:avLst/>
-          </a:prstGeom>
-          <a:noFill/>
-          <a:ln/>
-        </p:spPr>
-        <p:txBody>
-          <a:bodyPr wrap="square" lIns="0" tIns="0" rIns="0" bIns="0" rtlCol="0" anchor="t"/>
-          <a:lstStyle/>
-          <a:p>
-            <a:pPr indent="0" marL="0">
-              <a:buNone/>
-            </a:pPr>
-            <a:r>
-              <a:rPr lang="en-US" sz="2000" dirty="0">
-                <a:solidFill>
-                  <a:srgbClr val="1F2A30"/>
-                </a:solidFill>
-              </a:rPr>
-              <a:t>Python ha ripetuto il testo due volte. Il codice che gira non è per forza giusto: è la lezione più importante del corso.</a:t>
-            </a:r>
-            <a:endParaRPr lang="en-US" sz="2000" dirty="0"/>
-          </a:p>
-        </p:txBody>
-      </p:sp>
-      <p:sp>
-        <p:nvSpPr>
-          <p:cNvPr id="25" name="Slide Number Placeholder 0"/>
-          <p:cNvSpPr>
-            <a:spLocks noGrp="1"/>
-          </p:cNvSpPr>
-          <p:nvPr>
-            <p:ph type="sldNum" sz="quarter" idx="4294967295"/>
-          </p:nvPr>
-        </p:nvSpPr>
-        <p:spPr>
-          <a:xfrm>
-            <a:off x="11155680" y="6400800"/>
-            <a:ext cx="457200" cy="274320"/>
-          </a:xfrm>
-          <a:prstGeom prst="rect">
-            <a:avLst/>
-          </a:prstGeom>
-          <a:extLst>
-            <a:ext uri="{C572A759-6A51-4108-AA02-DFA0A04FC94B}">
-              <ma14:wrappingTextBoxFlag xmlns:ma14="http://schemas.microsoft.com/office/mac/drawingml/2011/main" val="0"/>
-            </a:ext>
-          </a:extLst>
-        </p:spPr>
-        <p:txBody>
-          <a:bodyPr/>
-          <a:lstStyle>
-            <a:lvl1pPr>
-              <a:defRPr sz="1000">
-                <a:solidFill>
-                  <a:srgbClr val="5C6F7B"/>
-                </a:solidFill>
-              </a:defRPr>
-            </a:lvl1pPr>
-          </a:lstStyle>
-          <a:p>
-            <a:pPr algn="r"/>
-            <a:fld id="{F7021451-1387-4CA6-816F-3879F97B5CBC}" type="slidenum">
-              <a:rPr b="0" lang="en-US"/>
               <a:t>12</a:t>
             </a:fld>
             <a:endParaRPr lang="en-US"/>
@@ -4501,7 +4915,7 @@
                   <a:srgbClr val="0F4C5C"/>
                 </a:solidFill>
               </a:rPr>
-              <a:t>Testo più numero</a:t>
+              <a:t>La trappola del passo 7</a:t>
             </a:r>
             <a:endParaRPr lang="en-US" sz="3600" dirty="0"/>
           </a:p>
@@ -4516,11 +4930,11 @@
         <p:spPr>
           <a:xfrm>
             <a:off x="548640" y="1737360"/>
-            <a:ext cx="5577840" cy="1188720"/>
+            <a:ext cx="5577840" cy="1645920"/>
           </a:xfrm>
           <a:prstGeom prst="roundRect">
             <a:avLst>
-              <a:gd name="adj" fmla="val 9231"/>
+              <a:gd name="adj" fmla="val 6667"/>
             </a:avLst>
           </a:prstGeom>
           <a:solidFill>
@@ -4574,7 +4988,7 @@
         <p:spPr>
           <a:xfrm>
             <a:off x="777240" y="2194560"/>
-            <a:ext cx="5120640" cy="594360"/>
+            <a:ext cx="5120640" cy="1051560"/>
           </a:xfrm>
           <a:prstGeom prst="rect">
             <a:avLst/>
@@ -4590,7 +5004,7 @@
               <a:buNone/>
             </a:pPr>
             <a:r>
-              <a:rPr lang="en-US" sz="1700" dirty="0">
+              <a:rPr lang="en-US" sz="2000" dirty="0">
                 <a:solidFill>
                   <a:srgbClr val="FFFFFF"/>
                 </a:solidFill>
@@ -4598,123 +5012,123 @@
                 <a:ea typeface="Courier New" pitchFamily="34" charset="-122"/>
                 <a:cs typeface="Courier New" pitchFamily="34" charset="-120"/>
               </a:rPr>
-              <a:t>print("Il capitale è " + capitale)</a:t>
-            </a:r>
-            <a:endParaRPr lang="en-US" sz="1700" dirty="0"/>
-          </a:p>
-        </p:txBody>
-      </p:sp>
-      <p:sp>
-        <p:nvSpPr>
-          <p:cNvPr id="6" name="card-err"/>
-          <p:cNvSpPr/>
-          <p:nvPr/>
-        </p:nvSpPr>
-        <p:spPr>
-          <a:xfrm>
-            <a:off x="548640" y="3154680"/>
-            <a:ext cx="5577840" cy="1463040"/>
-          </a:xfrm>
-          <a:prstGeom prst="roundRect">
-            <a:avLst>
-              <a:gd name="adj" fmla="val 7500"/>
-            </a:avLst>
-          </a:prstGeom>
-          <a:solidFill>
-            <a:srgbClr val="FBEAEA"/>
-          </a:solidFill>
-          <a:ln/>
-        </p:spPr>
-      </p:sp>
-      <p:sp>
-        <p:nvSpPr>
-          <p:cNvPr id="7" name="Text 5"/>
-          <p:cNvSpPr txBox="1"/>
-          <p:nvPr/>
-        </p:nvSpPr>
-        <p:spPr>
-          <a:xfrm>
-            <a:off x="777240" y="3291840"/>
-            <a:ext cx="1828800" cy="274320"/>
-          </a:xfrm>
-          <a:prstGeom prst="rect">
-            <a:avLst/>
-          </a:prstGeom>
-          <a:noFill/>
-          <a:ln/>
-        </p:spPr>
-        <p:txBody>
-          <a:bodyPr wrap="square" lIns="0" tIns="0" rIns="0" bIns="0" rtlCol="0" anchor="ctr"/>
-          <a:lstStyle/>
-          <a:p>
-            <a:pPr indent="0" marL="0">
-              <a:buNone/>
-            </a:pPr>
-            <a:r>
-              <a:rPr lang="en-US" sz="1100" b="1" spc="200" kern="0" dirty="0">
-                <a:solidFill>
-                  <a:srgbClr val="9E2A2B"/>
-                </a:solidFill>
-              </a:rPr>
-              <a:t>ERRORE</a:t>
-            </a:r>
-            <a:endParaRPr lang="en-US" sz="1100" dirty="0"/>
-          </a:p>
-        </p:txBody>
-      </p:sp>
-      <p:sp>
-        <p:nvSpPr>
-          <p:cNvPr id="8" name="Text 6"/>
-          <p:cNvSpPr txBox="1"/>
-          <p:nvPr/>
-        </p:nvSpPr>
-        <p:spPr>
-          <a:xfrm>
-            <a:off x="777240" y="3611880"/>
-            <a:ext cx="5120640" cy="868680"/>
-          </a:xfrm>
-          <a:prstGeom prst="rect">
-            <a:avLst/>
-          </a:prstGeom>
-          <a:noFill/>
-          <a:ln/>
-        </p:spPr>
-        <p:txBody>
-          <a:bodyPr wrap="square" lIns="0" tIns="0" rIns="0" bIns="0" rtlCol="0" anchor="t"/>
-          <a:lstStyle/>
-          <a:p>
-            <a:pPr indent="0" marL="0">
-              <a:buNone/>
-            </a:pPr>
-            <a:r>
-              <a:rPr lang="en-US" sz="1700" dirty="0">
-                <a:solidFill>
-                  <a:srgbClr val="9E2A2B"/>
+              <a:t>capitale_testo = "5000"</a:t>
+            </a:r>
+            <a:endParaRPr lang="en-US" sz="2000" dirty="0"/>
+          </a:p>
+          <a:p>
+            <a:pPr indent="0" marL="0">
+              <a:buNone/>
+            </a:pPr>
+            <a:r>
+              <a:rPr lang="en-US" sz="2000" dirty="0">
+                <a:solidFill>
+                  <a:srgbClr val="FFFFFF"/>
                 </a:solidFill>
                 <a:latin typeface="Courier New" pitchFamily="34" charset="0"/>
                 <a:ea typeface="Courier New" pitchFamily="34" charset="-122"/>
                 <a:cs typeface="Courier New" pitchFamily="34" charset="-120"/>
               </a:rPr>
-              <a:t>TypeError: can only concatenate</a:t>
-            </a:r>
-            <a:endParaRPr lang="en-US" sz="1700" dirty="0"/>
-          </a:p>
-          <a:p>
-            <a:pPr indent="0" marL="0">
-              <a:buNone/>
-            </a:pPr>
-            <a:r>
-              <a:rPr lang="en-US" sz="1700" dirty="0">
-                <a:solidFill>
-                  <a:srgbClr val="9E2A2B"/>
+              <a:t>print(capitale_testo * 2)</a:t>
+            </a:r>
+            <a:endParaRPr lang="en-US" sz="2000" dirty="0"/>
+          </a:p>
+        </p:txBody>
+      </p:sp>
+      <p:sp>
+        <p:nvSpPr>
+          <p:cNvPr id="6" name="card-out"/>
+          <p:cNvSpPr/>
+          <p:nvPr/>
+        </p:nvSpPr>
+        <p:spPr>
+          <a:xfrm>
+            <a:off x="548640" y="3657600"/>
+            <a:ext cx="5577840" cy="1280160"/>
+          </a:xfrm>
+          <a:prstGeom prst="roundRect">
+            <a:avLst>
+              <a:gd name="adj" fmla="val 8571"/>
+            </a:avLst>
+          </a:prstGeom>
+          <a:solidFill>
+            <a:srgbClr val="EEF3F4"/>
+          </a:solidFill>
+          <a:ln/>
+        </p:spPr>
+      </p:sp>
+      <p:sp>
+        <p:nvSpPr>
+          <p:cNvPr id="7" name="Text 5"/>
+          <p:cNvSpPr txBox="1"/>
+          <p:nvPr/>
+        </p:nvSpPr>
+        <p:spPr>
+          <a:xfrm>
+            <a:off x="777240" y="3794760"/>
+            <a:ext cx="1828800" cy="274320"/>
+          </a:xfrm>
+          <a:prstGeom prst="rect">
+            <a:avLst/>
+          </a:prstGeom>
+          <a:noFill/>
+          <a:ln/>
+        </p:spPr>
+        <p:txBody>
+          <a:bodyPr wrap="square" lIns="0" tIns="0" rIns="0" bIns="0" rtlCol="0" anchor="ctr"/>
+          <a:lstStyle/>
+          <a:p>
+            <a:pPr indent="0" marL="0">
+              <a:buNone/>
+            </a:pPr>
+            <a:r>
+              <a:rPr lang="en-US" sz="1100" b="1" spc="200" kern="0" dirty="0">
+                <a:solidFill>
+                  <a:srgbClr val="5C6F7B"/>
+                </a:solidFill>
+              </a:rPr>
+              <a:t>OUTPUT</a:t>
+            </a:r>
+            <a:endParaRPr lang="en-US" sz="1100" dirty="0"/>
+          </a:p>
+        </p:txBody>
+      </p:sp>
+      <p:sp>
+        <p:nvSpPr>
+          <p:cNvPr id="8" name="Text 6"/>
+          <p:cNvSpPr txBox="1"/>
+          <p:nvPr/>
+        </p:nvSpPr>
+        <p:spPr>
+          <a:xfrm>
+            <a:off x="777240" y="4114800"/>
+            <a:ext cx="5120640" cy="685800"/>
+          </a:xfrm>
+          <a:prstGeom prst="rect">
+            <a:avLst/>
+          </a:prstGeom>
+          <a:noFill/>
+          <a:ln/>
+        </p:spPr>
+        <p:txBody>
+          <a:bodyPr wrap="square" lIns="0" tIns="0" rIns="0" bIns="0" rtlCol="0" anchor="t"/>
+          <a:lstStyle/>
+          <a:p>
+            <a:pPr indent="0" marL="0">
+              <a:buNone/>
+            </a:pPr>
+            <a:r>
+              <a:rPr lang="en-US" sz="2400" dirty="0">
+                <a:solidFill>
+                  <a:srgbClr val="1F2A30"/>
                 </a:solidFill>
                 <a:latin typeface="Courier New" pitchFamily="34" charset="0"/>
                 <a:ea typeface="Courier New" pitchFamily="34" charset="-122"/>
                 <a:cs typeface="Courier New" pitchFamily="34" charset="-120"/>
               </a:rPr>
-              <a:t>str (not "int") to str</a:t>
-            </a:r>
-            <a:endParaRPr lang="en-US" sz="1700" dirty="0"/>
+              <a:t>50005000</a:t>
+            </a:r>
+            <a:endParaRPr lang="en-US" sz="2400" dirty="0"/>
           </a:p>
         </p:txBody>
       </p:sp>
@@ -4727,260 +5141,80 @@
         <p:spPr>
           <a:xfrm>
             <a:off x="6675120" y="1737360"/>
-            <a:ext cx="4937760" cy="457200"/>
-          </a:xfrm>
-          <a:prstGeom prst="rect">
-            <a:avLst/>
-          </a:prstGeom>
-          <a:noFill/>
-          <a:ln/>
-        </p:spPr>
-        <p:txBody>
-          <a:bodyPr wrap="square" lIns="0" tIns="0" rIns="0" bIns="0" rtlCol="0" anchor="ctr"/>
-          <a:lstStyle/>
-          <a:p>
-            <a:pPr indent="0" marL="0">
-              <a:buNone/>
-            </a:pPr>
-            <a:r>
-              <a:rPr lang="en-US" sz="2200" b="1" dirty="0">
+            <a:ext cx="4937760" cy="1645920"/>
+          </a:xfrm>
+          <a:prstGeom prst="rect">
+            <a:avLst/>
+          </a:prstGeom>
+          <a:noFill/>
+          <a:ln/>
+        </p:spPr>
+        <p:txBody>
+          <a:bodyPr wrap="square" lIns="0" tIns="0" rIns="0" bIns="0" rtlCol="0" anchor="t"/>
+          <a:lstStyle/>
+          <a:p>
+            <a:pPr indent="0" marL="0">
+              <a:buNone/>
+            </a:pPr>
+            <a:r>
+              <a:rPr lang="en-US" sz="3200" b="1" dirty="0">
+                <a:solidFill>
+                  <a:srgbClr val="9E2A2B"/>
+                </a:solidFill>
+              </a:rPr>
+              <a:t>Nessun errore.</a:t>
+            </a:r>
+            <a:endParaRPr lang="en-US" sz="3200" dirty="0"/>
+          </a:p>
+          <a:p>
+            <a:pPr indent="0" marL="0">
+              <a:buNone/>
+            </a:pPr>
+            <a:r>
+              <a:rPr lang="en-US" sz="3200" b="1" dirty="0">
+                <a:solidFill>
+                  <a:srgbClr val="9E2A2B"/>
+                </a:solidFill>
+              </a:rPr>
+              <a:t>Risultato sbagliato.</a:t>
+            </a:r>
+            <a:endParaRPr lang="en-US" sz="3200" dirty="0"/>
+          </a:p>
+        </p:txBody>
+      </p:sp>
+      <p:sp>
+        <p:nvSpPr>
+          <p:cNvPr id="10" name="Text 8"/>
+          <p:cNvSpPr txBox="1"/>
+          <p:nvPr/>
+        </p:nvSpPr>
+        <p:spPr>
+          <a:xfrm>
+            <a:off x="6675120" y="3566160"/>
+            <a:ext cx="4937760" cy="1463040"/>
+          </a:xfrm>
+          <a:prstGeom prst="rect">
+            <a:avLst/>
+          </a:prstGeom>
+          <a:noFill/>
+          <a:ln/>
+        </p:spPr>
+        <p:txBody>
+          <a:bodyPr wrap="square" lIns="0" tIns="0" rIns="0" bIns="0" rtlCol="0" anchor="t"/>
+          <a:lstStyle/>
+          <a:p>
+            <a:pPr indent="0" marL="0">
+              <a:buNone/>
+            </a:pPr>
+            <a:r>
+              <a:rPr lang="en-US" sz="2000" dirty="0">
                 <a:solidFill>
                   <a:srgbClr val="1F2A30"/>
                 </a:solidFill>
               </a:rPr>
-              <a:t>Due modi per correggere</a:t>
-            </a:r>
-            <a:endParaRPr lang="en-US" sz="2200" dirty="0"/>
-          </a:p>
-        </p:txBody>
-      </p:sp>
-      <p:sp>
-        <p:nvSpPr>
-          <p:cNvPr id="10" name="card-code"/>
-          <p:cNvSpPr/>
-          <p:nvPr/>
-        </p:nvSpPr>
-        <p:spPr>
-          <a:xfrm>
-            <a:off x="6675120" y="2377440"/>
-            <a:ext cx="4937760" cy="1097280"/>
-          </a:xfrm>
-          <a:prstGeom prst="roundRect">
-            <a:avLst>
-              <a:gd name="adj" fmla="val 10000"/>
-            </a:avLst>
-          </a:prstGeom>
-          <a:solidFill>
-            <a:srgbClr val="1F2A30"/>
-          </a:solidFill>
-          <a:ln/>
-        </p:spPr>
-      </p:sp>
-      <p:sp>
-        <p:nvSpPr>
-          <p:cNvPr id="11" name="Text 9"/>
-          <p:cNvSpPr txBox="1"/>
-          <p:nvPr/>
-        </p:nvSpPr>
-        <p:spPr>
-          <a:xfrm>
-            <a:off x="6903720" y="2514600"/>
-            <a:ext cx="1828800" cy="274320"/>
-          </a:xfrm>
-          <a:prstGeom prst="rect">
-            <a:avLst/>
-          </a:prstGeom>
-          <a:noFill/>
-          <a:ln/>
-        </p:spPr>
-        <p:txBody>
-          <a:bodyPr wrap="square" lIns="0" tIns="0" rIns="0" bIns="0" rtlCol="0" anchor="ctr"/>
-          <a:lstStyle/>
-          <a:p>
-            <a:pPr indent="0" marL="0">
-              <a:buNone/>
-            </a:pPr>
-            <a:r>
-              <a:rPr lang="en-US" sz="1100" b="1" spc="200" kern="0" dirty="0">
-                <a:solidFill>
-                  <a:srgbClr val="E09F3E"/>
-                </a:solidFill>
-              </a:rPr>
-              <a:t>PYTHON</a:t>
-            </a:r>
-            <a:endParaRPr lang="en-US" sz="1100" dirty="0"/>
-          </a:p>
-        </p:txBody>
-      </p:sp>
-      <p:sp>
-        <p:nvSpPr>
-          <p:cNvPr id="12" name="Text 10"/>
-          <p:cNvSpPr txBox="1"/>
-          <p:nvPr/>
-        </p:nvSpPr>
-        <p:spPr>
-          <a:xfrm>
-            <a:off x="6903720" y="2834640"/>
-            <a:ext cx="4480560" cy="502920"/>
-          </a:xfrm>
-          <a:prstGeom prst="rect">
-            <a:avLst/>
-          </a:prstGeom>
-          <a:noFill/>
-          <a:ln/>
-        </p:spPr>
-        <p:txBody>
-          <a:bodyPr wrap="square" lIns="0" tIns="0" rIns="0" bIns="0" rtlCol="0" anchor="t"/>
-          <a:lstStyle/>
-          <a:p>
-            <a:pPr indent="0" marL="0">
-              <a:buNone/>
-            </a:pPr>
-            <a:r>
-              <a:rPr lang="en-US" sz="1500" dirty="0">
-                <a:solidFill>
-                  <a:srgbClr val="FFFFFF"/>
-                </a:solidFill>
-                <a:latin typeface="Courier New" pitchFamily="34" charset="0"/>
-                <a:ea typeface="Courier New" pitchFamily="34" charset="-122"/>
-                <a:cs typeface="Courier New" pitchFamily="34" charset="-120"/>
-              </a:rPr>
-              <a:t>"Il capitale è " + str(capitale)</a:t>
-            </a:r>
-            <a:endParaRPr lang="en-US" sz="1500" dirty="0"/>
-          </a:p>
-        </p:txBody>
-      </p:sp>
-      <p:sp>
-        <p:nvSpPr>
-          <p:cNvPr id="13" name="card-code"/>
-          <p:cNvSpPr/>
-          <p:nvPr/>
-        </p:nvSpPr>
-        <p:spPr>
-          <a:xfrm>
-            <a:off x="6675120" y="3657600"/>
-            <a:ext cx="4937760" cy="1097280"/>
-          </a:xfrm>
-          <a:prstGeom prst="roundRect">
-            <a:avLst>
-              <a:gd name="adj" fmla="val 10000"/>
-            </a:avLst>
-          </a:prstGeom>
-          <a:solidFill>
-            <a:srgbClr val="1F2A30"/>
-          </a:solidFill>
-          <a:ln/>
-        </p:spPr>
-      </p:sp>
-      <p:sp>
-        <p:nvSpPr>
-          <p:cNvPr id="14" name="Text 12"/>
-          <p:cNvSpPr txBox="1"/>
-          <p:nvPr/>
-        </p:nvSpPr>
-        <p:spPr>
-          <a:xfrm>
-            <a:off x="6903720" y="3794760"/>
-            <a:ext cx="1828800" cy="274320"/>
-          </a:xfrm>
-          <a:prstGeom prst="rect">
-            <a:avLst/>
-          </a:prstGeom>
-          <a:noFill/>
-          <a:ln/>
-        </p:spPr>
-        <p:txBody>
-          <a:bodyPr wrap="square" lIns="0" tIns="0" rIns="0" bIns="0" rtlCol="0" anchor="ctr"/>
-          <a:lstStyle/>
-          <a:p>
-            <a:pPr indent="0" marL="0">
-              <a:buNone/>
-            </a:pPr>
-            <a:r>
-              <a:rPr lang="en-US" sz="1100" b="1" spc="200" kern="0" dirty="0">
-                <a:solidFill>
-                  <a:srgbClr val="E09F3E"/>
-                </a:solidFill>
-              </a:rPr>
-              <a:t>PYTHON</a:t>
-            </a:r>
-            <a:endParaRPr lang="en-US" sz="1100" dirty="0"/>
-          </a:p>
-        </p:txBody>
-      </p:sp>
-      <p:sp>
-        <p:nvSpPr>
-          <p:cNvPr id="15" name="Text 13"/>
-          <p:cNvSpPr txBox="1"/>
-          <p:nvPr/>
-        </p:nvSpPr>
-        <p:spPr>
-          <a:xfrm>
-            <a:off x="6903720" y="4114800"/>
-            <a:ext cx="4480560" cy="502920"/>
-          </a:xfrm>
-          <a:prstGeom prst="rect">
-            <a:avLst/>
-          </a:prstGeom>
-          <a:noFill/>
-          <a:ln/>
-        </p:spPr>
-        <p:txBody>
-          <a:bodyPr wrap="square" lIns="0" tIns="0" rIns="0" bIns="0" rtlCol="0" anchor="t"/>
-          <a:lstStyle/>
-          <a:p>
-            <a:pPr indent="0" marL="0">
-              <a:buNone/>
-            </a:pPr>
-            <a:r>
-              <a:rPr lang="en-US" sz="1500" dirty="0">
-                <a:solidFill>
-                  <a:srgbClr val="FFFFFF"/>
-                </a:solidFill>
-                <a:latin typeface="Courier New" pitchFamily="34" charset="0"/>
-                <a:ea typeface="Courier New" pitchFamily="34" charset="-122"/>
-                <a:cs typeface="Courier New" pitchFamily="34" charset="-120"/>
-              </a:rPr>
-              <a:t>f"Il capitale è {capitale}"</a:t>
-            </a:r>
-            <a:endParaRPr lang="en-US" sz="1500" dirty="0"/>
-          </a:p>
-        </p:txBody>
-      </p:sp>
-      <p:sp>
-        <p:nvSpPr>
-          <p:cNvPr id="16" name="Text 14"/>
-          <p:cNvSpPr txBox="1"/>
-          <p:nvPr/>
-        </p:nvSpPr>
-        <p:spPr>
-          <a:xfrm>
-            <a:off x="548640" y="5120640"/>
-            <a:ext cx="11064240" cy="548640"/>
-          </a:xfrm>
-          <a:prstGeom prst="rect">
-            <a:avLst/>
-          </a:prstGeom>
-          <a:noFill/>
-          <a:ln/>
-        </p:spPr>
-        <p:txBody>
-          <a:bodyPr wrap="square" lIns="0" tIns="0" rIns="0" bIns="0" rtlCol="0" anchor="ctr"/>
-          <a:lstStyle/>
-          <a:p>
-            <a:pPr indent="0" marL="0">
-              <a:buNone/>
-            </a:pPr>
-            <a:r>
-              <a:rPr lang="en-US" sz="1800" i="1" dirty="0">
-                <a:solidFill>
-                  <a:srgbClr val="0F4C5C"/>
-                </a:solidFill>
-              </a:rPr>
-              <a:t>Python non indovina: testo e numeri vanno trattati in modo esplicito.</a:t>
-            </a:r>
-            <a:endParaRPr lang="en-US" sz="1800" dirty="0"/>
+              <a:t>Python ha ripetuto il testo due volte. Il codice che gira non è per forza giusto: è la lezione più importante del corso.</a:t>
+            </a:r>
+            <a:endParaRPr lang="en-US" sz="2000" dirty="0"/>
           </a:p>
         </p:txBody>
       </p:sp>
@@ -5040,6 +5274,591 @@
 <file path=ppt/slides/slide14.xml><?xml version="1.0" encoding="utf-8"?>
 <p:sld xmlns:a="http://schemas.openxmlformats.org/drawingml/2006/main" xmlns:r="http://schemas.openxmlformats.org/officeDocument/2006/relationships" xmlns:p="http://schemas.openxmlformats.org/presentationml/2006/main">
   <p:cSld name="Slide 14">
+    <p:spTree>
+      <p:nvGrpSpPr>
+        <p:cNvPr id="1" name=""/>
+        <p:cNvGrpSpPr/>
+        <p:nvPr/>
+      </p:nvGrpSpPr>
+      <p:grpSpPr>
+        <a:xfrm>
+          <a:off x="0" y="0"/>
+          <a:ext cx="0" cy="0"/>
+          <a:chOff x="0" y="0"/>
+          <a:chExt cx="0" cy="0"/>
+        </a:xfrm>
+      </p:grpSpPr>
+      <p:sp>
+        <p:nvSpPr>
+          <p:cNvPr id="2" name="Text 0"/>
+          <p:cNvSpPr/>
+          <p:nvPr>
+            <p:ph idx="100" type="title" hasCustomPrompt="1"/>
+          </p:nvPr>
+        </p:nvSpPr>
+        <p:spPr>
+          <a:xfrm>
+            <a:off x="548640" y="365760"/>
+            <a:ext cx="11064240" cy="822960"/>
+          </a:xfrm>
+          <a:prstGeom prst="rect">
+            <a:avLst/>
+          </a:prstGeom>
+          <a:noFill/>
+          <a:ln/>
+        </p:spPr>
+        <p:txBody>
+          <a:bodyPr wrap="square" lIns="0" tIns="0" rIns="0" bIns="0" rtlCol="0" anchor="ctr"/>
+          <a:lstStyle/>
+          <a:p>
+            <a:pPr algn="l" indent="0" marL="0">
+              <a:buNone/>
+            </a:pPr>
+            <a:r>
+              <a:rPr lang="en-US" sz="3600" b="1" dirty="0">
+                <a:solidFill>
+                  <a:srgbClr val="0F4C5C"/>
+                </a:solidFill>
+              </a:rPr>
+              <a:t>Testo più numero</a:t>
+            </a:r>
+            <a:endParaRPr lang="en-US" sz="3600" dirty="0"/>
+          </a:p>
+        </p:txBody>
+      </p:sp>
+      <p:sp>
+        <p:nvSpPr>
+          <p:cNvPr id="3" name="card-code"/>
+          <p:cNvSpPr/>
+          <p:nvPr/>
+        </p:nvSpPr>
+        <p:spPr>
+          <a:xfrm>
+            <a:off x="548640" y="1737360"/>
+            <a:ext cx="5577840" cy="1188720"/>
+          </a:xfrm>
+          <a:prstGeom prst="roundRect">
+            <a:avLst>
+              <a:gd name="adj" fmla="val 9231"/>
+            </a:avLst>
+          </a:prstGeom>
+          <a:solidFill>
+            <a:srgbClr val="1F2A30"/>
+          </a:solidFill>
+          <a:ln/>
+        </p:spPr>
+      </p:sp>
+      <p:sp>
+        <p:nvSpPr>
+          <p:cNvPr id="4" name="Text 2"/>
+          <p:cNvSpPr txBox="1"/>
+          <p:nvPr/>
+        </p:nvSpPr>
+        <p:spPr>
+          <a:xfrm>
+            <a:off x="777240" y="1874520"/>
+            <a:ext cx="1828800" cy="274320"/>
+          </a:xfrm>
+          <a:prstGeom prst="rect">
+            <a:avLst/>
+          </a:prstGeom>
+          <a:noFill/>
+          <a:ln/>
+        </p:spPr>
+        <p:txBody>
+          <a:bodyPr wrap="square" lIns="0" tIns="0" rIns="0" bIns="0" rtlCol="0" anchor="ctr"/>
+          <a:lstStyle/>
+          <a:p>
+            <a:pPr indent="0" marL="0">
+              <a:buNone/>
+            </a:pPr>
+            <a:r>
+              <a:rPr lang="en-US" sz="1100" b="1" spc="200" kern="0" dirty="0">
+                <a:solidFill>
+                  <a:srgbClr val="E09F3E"/>
+                </a:solidFill>
+              </a:rPr>
+              <a:t>PYTHON</a:t>
+            </a:r>
+            <a:endParaRPr lang="en-US" sz="1100" dirty="0"/>
+          </a:p>
+        </p:txBody>
+      </p:sp>
+      <p:sp>
+        <p:nvSpPr>
+          <p:cNvPr id="5" name="Text 3"/>
+          <p:cNvSpPr txBox="1"/>
+          <p:nvPr/>
+        </p:nvSpPr>
+        <p:spPr>
+          <a:xfrm>
+            <a:off x="777240" y="2194560"/>
+            <a:ext cx="5120640" cy="594360"/>
+          </a:xfrm>
+          <a:prstGeom prst="rect">
+            <a:avLst/>
+          </a:prstGeom>
+          <a:noFill/>
+          <a:ln/>
+        </p:spPr>
+        <p:txBody>
+          <a:bodyPr wrap="square" lIns="0" tIns="0" rIns="0" bIns="0" rtlCol="0" anchor="t"/>
+          <a:lstStyle/>
+          <a:p>
+            <a:pPr indent="0" marL="0">
+              <a:buNone/>
+            </a:pPr>
+            <a:r>
+              <a:rPr lang="en-US" sz="1700" dirty="0">
+                <a:solidFill>
+                  <a:srgbClr val="FFFFFF"/>
+                </a:solidFill>
+                <a:latin typeface="Courier New" pitchFamily="34" charset="0"/>
+                <a:ea typeface="Courier New" pitchFamily="34" charset="-122"/>
+                <a:cs typeface="Courier New" pitchFamily="34" charset="-120"/>
+              </a:rPr>
+              <a:t>print("Il capitale è " + capitale)</a:t>
+            </a:r>
+            <a:endParaRPr lang="en-US" sz="1700" dirty="0"/>
+          </a:p>
+        </p:txBody>
+      </p:sp>
+      <p:sp>
+        <p:nvSpPr>
+          <p:cNvPr id="6" name="card-err"/>
+          <p:cNvSpPr/>
+          <p:nvPr/>
+        </p:nvSpPr>
+        <p:spPr>
+          <a:xfrm>
+            <a:off x="548640" y="3154680"/>
+            <a:ext cx="5577840" cy="1463040"/>
+          </a:xfrm>
+          <a:prstGeom prst="roundRect">
+            <a:avLst>
+              <a:gd name="adj" fmla="val 7500"/>
+            </a:avLst>
+          </a:prstGeom>
+          <a:solidFill>
+            <a:srgbClr val="FBEAEA"/>
+          </a:solidFill>
+          <a:ln/>
+        </p:spPr>
+      </p:sp>
+      <p:sp>
+        <p:nvSpPr>
+          <p:cNvPr id="7" name="Text 5"/>
+          <p:cNvSpPr txBox="1"/>
+          <p:nvPr/>
+        </p:nvSpPr>
+        <p:spPr>
+          <a:xfrm>
+            <a:off x="777240" y="3291840"/>
+            <a:ext cx="1828800" cy="274320"/>
+          </a:xfrm>
+          <a:prstGeom prst="rect">
+            <a:avLst/>
+          </a:prstGeom>
+          <a:noFill/>
+          <a:ln/>
+        </p:spPr>
+        <p:txBody>
+          <a:bodyPr wrap="square" lIns="0" tIns="0" rIns="0" bIns="0" rtlCol="0" anchor="ctr"/>
+          <a:lstStyle/>
+          <a:p>
+            <a:pPr indent="0" marL="0">
+              <a:buNone/>
+            </a:pPr>
+            <a:r>
+              <a:rPr lang="en-US" sz="1100" b="1" spc="200" kern="0" dirty="0">
+                <a:solidFill>
+                  <a:srgbClr val="9E2A2B"/>
+                </a:solidFill>
+              </a:rPr>
+              <a:t>ERRORE</a:t>
+            </a:r>
+            <a:endParaRPr lang="en-US" sz="1100" dirty="0"/>
+          </a:p>
+        </p:txBody>
+      </p:sp>
+      <p:sp>
+        <p:nvSpPr>
+          <p:cNvPr id="8" name="Text 6"/>
+          <p:cNvSpPr txBox="1"/>
+          <p:nvPr/>
+        </p:nvSpPr>
+        <p:spPr>
+          <a:xfrm>
+            <a:off x="777240" y="3611880"/>
+            <a:ext cx="5120640" cy="868680"/>
+          </a:xfrm>
+          <a:prstGeom prst="rect">
+            <a:avLst/>
+          </a:prstGeom>
+          <a:noFill/>
+          <a:ln/>
+        </p:spPr>
+        <p:txBody>
+          <a:bodyPr wrap="square" lIns="0" tIns="0" rIns="0" bIns="0" rtlCol="0" anchor="t"/>
+          <a:lstStyle/>
+          <a:p>
+            <a:pPr indent="0" marL="0">
+              <a:buNone/>
+            </a:pPr>
+            <a:r>
+              <a:rPr lang="en-US" sz="1700" dirty="0">
+                <a:solidFill>
+                  <a:srgbClr val="9E2A2B"/>
+                </a:solidFill>
+                <a:latin typeface="Courier New" pitchFamily="34" charset="0"/>
+                <a:ea typeface="Courier New" pitchFamily="34" charset="-122"/>
+                <a:cs typeface="Courier New" pitchFamily="34" charset="-120"/>
+              </a:rPr>
+              <a:t>TypeError: can only concatenate</a:t>
+            </a:r>
+            <a:endParaRPr lang="en-US" sz="1700" dirty="0"/>
+          </a:p>
+          <a:p>
+            <a:pPr indent="0" marL="0">
+              <a:buNone/>
+            </a:pPr>
+            <a:r>
+              <a:rPr lang="en-US" sz="1700" dirty="0">
+                <a:solidFill>
+                  <a:srgbClr val="9E2A2B"/>
+                </a:solidFill>
+                <a:latin typeface="Courier New" pitchFamily="34" charset="0"/>
+                <a:ea typeface="Courier New" pitchFamily="34" charset="-122"/>
+                <a:cs typeface="Courier New" pitchFamily="34" charset="-120"/>
+              </a:rPr>
+              <a:t>str (not "int") to str</a:t>
+            </a:r>
+            <a:endParaRPr lang="en-US" sz="1700" dirty="0"/>
+          </a:p>
+        </p:txBody>
+      </p:sp>
+      <p:sp>
+        <p:nvSpPr>
+          <p:cNvPr id="9" name="Text 7"/>
+          <p:cNvSpPr txBox="1"/>
+          <p:nvPr/>
+        </p:nvSpPr>
+        <p:spPr>
+          <a:xfrm>
+            <a:off x="6675120" y="1737360"/>
+            <a:ext cx="4937760" cy="457200"/>
+          </a:xfrm>
+          <a:prstGeom prst="rect">
+            <a:avLst/>
+          </a:prstGeom>
+          <a:noFill/>
+          <a:ln/>
+        </p:spPr>
+        <p:txBody>
+          <a:bodyPr wrap="square" lIns="0" tIns="0" rIns="0" bIns="0" rtlCol="0" anchor="ctr"/>
+          <a:lstStyle/>
+          <a:p>
+            <a:pPr indent="0" marL="0">
+              <a:buNone/>
+            </a:pPr>
+            <a:r>
+              <a:rPr lang="en-US" sz="2200" b="1" dirty="0">
+                <a:solidFill>
+                  <a:srgbClr val="1F2A30"/>
+                </a:solidFill>
+              </a:rPr>
+              <a:t>Due modi per correggere</a:t>
+            </a:r>
+            <a:endParaRPr lang="en-US" sz="2200" dirty="0"/>
+          </a:p>
+        </p:txBody>
+      </p:sp>
+      <p:sp>
+        <p:nvSpPr>
+          <p:cNvPr id="10" name="card-code"/>
+          <p:cNvSpPr/>
+          <p:nvPr/>
+        </p:nvSpPr>
+        <p:spPr>
+          <a:xfrm>
+            <a:off x="6675120" y="2377440"/>
+            <a:ext cx="4937760" cy="1097280"/>
+          </a:xfrm>
+          <a:prstGeom prst="roundRect">
+            <a:avLst>
+              <a:gd name="adj" fmla="val 10000"/>
+            </a:avLst>
+          </a:prstGeom>
+          <a:solidFill>
+            <a:srgbClr val="1F2A30"/>
+          </a:solidFill>
+          <a:ln/>
+        </p:spPr>
+      </p:sp>
+      <p:sp>
+        <p:nvSpPr>
+          <p:cNvPr id="11" name="Text 9"/>
+          <p:cNvSpPr txBox="1"/>
+          <p:nvPr/>
+        </p:nvSpPr>
+        <p:spPr>
+          <a:xfrm>
+            <a:off x="6903720" y="2514600"/>
+            <a:ext cx="1828800" cy="274320"/>
+          </a:xfrm>
+          <a:prstGeom prst="rect">
+            <a:avLst/>
+          </a:prstGeom>
+          <a:noFill/>
+          <a:ln/>
+        </p:spPr>
+        <p:txBody>
+          <a:bodyPr wrap="square" lIns="0" tIns="0" rIns="0" bIns="0" rtlCol="0" anchor="ctr"/>
+          <a:lstStyle/>
+          <a:p>
+            <a:pPr indent="0" marL="0">
+              <a:buNone/>
+            </a:pPr>
+            <a:r>
+              <a:rPr lang="en-US" sz="1100" b="1" spc="200" kern="0" dirty="0">
+                <a:solidFill>
+                  <a:srgbClr val="E09F3E"/>
+                </a:solidFill>
+              </a:rPr>
+              <a:t>PYTHON</a:t>
+            </a:r>
+            <a:endParaRPr lang="en-US" sz="1100" dirty="0"/>
+          </a:p>
+        </p:txBody>
+      </p:sp>
+      <p:sp>
+        <p:nvSpPr>
+          <p:cNvPr id="12" name="Text 10"/>
+          <p:cNvSpPr txBox="1"/>
+          <p:nvPr/>
+        </p:nvSpPr>
+        <p:spPr>
+          <a:xfrm>
+            <a:off x="6903720" y="2834640"/>
+            <a:ext cx="4480560" cy="502920"/>
+          </a:xfrm>
+          <a:prstGeom prst="rect">
+            <a:avLst/>
+          </a:prstGeom>
+          <a:noFill/>
+          <a:ln/>
+        </p:spPr>
+        <p:txBody>
+          <a:bodyPr wrap="square" lIns="0" tIns="0" rIns="0" bIns="0" rtlCol="0" anchor="t"/>
+          <a:lstStyle/>
+          <a:p>
+            <a:pPr indent="0" marL="0">
+              <a:buNone/>
+            </a:pPr>
+            <a:r>
+              <a:rPr lang="en-US" sz="1500" dirty="0">
+                <a:solidFill>
+                  <a:srgbClr val="FFFFFF"/>
+                </a:solidFill>
+                <a:latin typeface="Courier New" pitchFamily="34" charset="0"/>
+                <a:ea typeface="Courier New" pitchFamily="34" charset="-122"/>
+                <a:cs typeface="Courier New" pitchFamily="34" charset="-120"/>
+              </a:rPr>
+              <a:t>"Il capitale è " + str(capitale)</a:t>
+            </a:r>
+            <a:endParaRPr lang="en-US" sz="1500" dirty="0"/>
+          </a:p>
+        </p:txBody>
+      </p:sp>
+      <p:sp>
+        <p:nvSpPr>
+          <p:cNvPr id="13" name="card-code"/>
+          <p:cNvSpPr/>
+          <p:nvPr/>
+        </p:nvSpPr>
+        <p:spPr>
+          <a:xfrm>
+            <a:off x="6675120" y="3657600"/>
+            <a:ext cx="4937760" cy="1097280"/>
+          </a:xfrm>
+          <a:prstGeom prst="roundRect">
+            <a:avLst>
+              <a:gd name="adj" fmla="val 10000"/>
+            </a:avLst>
+          </a:prstGeom>
+          <a:solidFill>
+            <a:srgbClr val="1F2A30"/>
+          </a:solidFill>
+          <a:ln/>
+        </p:spPr>
+      </p:sp>
+      <p:sp>
+        <p:nvSpPr>
+          <p:cNvPr id="14" name="Text 12"/>
+          <p:cNvSpPr txBox="1"/>
+          <p:nvPr/>
+        </p:nvSpPr>
+        <p:spPr>
+          <a:xfrm>
+            <a:off x="6903720" y="3794760"/>
+            <a:ext cx="1828800" cy="274320"/>
+          </a:xfrm>
+          <a:prstGeom prst="rect">
+            <a:avLst/>
+          </a:prstGeom>
+          <a:noFill/>
+          <a:ln/>
+        </p:spPr>
+        <p:txBody>
+          <a:bodyPr wrap="square" lIns="0" tIns="0" rIns="0" bIns="0" rtlCol="0" anchor="ctr"/>
+          <a:lstStyle/>
+          <a:p>
+            <a:pPr indent="0" marL="0">
+              <a:buNone/>
+            </a:pPr>
+            <a:r>
+              <a:rPr lang="en-US" sz="1100" b="1" spc="200" kern="0" dirty="0">
+                <a:solidFill>
+                  <a:srgbClr val="E09F3E"/>
+                </a:solidFill>
+              </a:rPr>
+              <a:t>PYTHON</a:t>
+            </a:r>
+            <a:endParaRPr lang="en-US" sz="1100" dirty="0"/>
+          </a:p>
+        </p:txBody>
+      </p:sp>
+      <p:sp>
+        <p:nvSpPr>
+          <p:cNvPr id="15" name="Text 13"/>
+          <p:cNvSpPr txBox="1"/>
+          <p:nvPr/>
+        </p:nvSpPr>
+        <p:spPr>
+          <a:xfrm>
+            <a:off x="6903720" y="4114800"/>
+            <a:ext cx="4480560" cy="502920"/>
+          </a:xfrm>
+          <a:prstGeom prst="rect">
+            <a:avLst/>
+          </a:prstGeom>
+          <a:noFill/>
+          <a:ln/>
+        </p:spPr>
+        <p:txBody>
+          <a:bodyPr wrap="square" lIns="0" tIns="0" rIns="0" bIns="0" rtlCol="0" anchor="t"/>
+          <a:lstStyle/>
+          <a:p>
+            <a:pPr indent="0" marL="0">
+              <a:buNone/>
+            </a:pPr>
+            <a:r>
+              <a:rPr lang="en-US" sz="1500" dirty="0">
+                <a:solidFill>
+                  <a:srgbClr val="FFFFFF"/>
+                </a:solidFill>
+                <a:latin typeface="Courier New" pitchFamily="34" charset="0"/>
+                <a:ea typeface="Courier New" pitchFamily="34" charset="-122"/>
+                <a:cs typeface="Courier New" pitchFamily="34" charset="-120"/>
+              </a:rPr>
+              <a:t>f"Il capitale è {capitale}"</a:t>
+            </a:r>
+            <a:endParaRPr lang="en-US" sz="1500" dirty="0"/>
+          </a:p>
+        </p:txBody>
+      </p:sp>
+      <p:sp>
+        <p:nvSpPr>
+          <p:cNvPr id="16" name="Text 14"/>
+          <p:cNvSpPr txBox="1"/>
+          <p:nvPr/>
+        </p:nvSpPr>
+        <p:spPr>
+          <a:xfrm>
+            <a:off x="548640" y="5120640"/>
+            <a:ext cx="11064240" cy="548640"/>
+          </a:xfrm>
+          <a:prstGeom prst="rect">
+            <a:avLst/>
+          </a:prstGeom>
+          <a:noFill/>
+          <a:ln/>
+        </p:spPr>
+        <p:txBody>
+          <a:bodyPr wrap="square" lIns="0" tIns="0" rIns="0" bIns="0" rtlCol="0" anchor="ctr"/>
+          <a:lstStyle/>
+          <a:p>
+            <a:pPr indent="0" marL="0">
+              <a:buNone/>
+            </a:pPr>
+            <a:r>
+              <a:rPr lang="en-US" sz="1800" i="1" dirty="0">
+                <a:solidFill>
+                  <a:srgbClr val="0F4C5C"/>
+                </a:solidFill>
+              </a:rPr>
+              <a:t>Python non indovina: testo e numeri vanno trattati in modo esplicito.</a:t>
+            </a:r>
+            <a:endParaRPr lang="en-US" sz="1800" dirty="0"/>
+          </a:p>
+        </p:txBody>
+      </p:sp>
+      <p:sp>
+        <p:nvSpPr>
+          <p:cNvPr id="25" name="Slide Number Placeholder 0"/>
+          <p:cNvSpPr>
+            <a:spLocks noGrp="1"/>
+          </p:cNvSpPr>
+          <p:nvPr>
+            <p:ph type="sldNum" sz="quarter" idx="4294967295"/>
+          </p:nvPr>
+        </p:nvSpPr>
+        <p:spPr>
+          <a:xfrm>
+            <a:off x="11155680" y="6400800"/>
+            <a:ext cx="457200" cy="274320"/>
+          </a:xfrm>
+          <a:prstGeom prst="rect">
+            <a:avLst/>
+          </a:prstGeom>
+          <a:extLst>
+            <a:ext uri="{C572A759-6A51-4108-AA02-DFA0A04FC94B}">
+              <ma14:wrappingTextBoxFlag xmlns:ma14="http://schemas.microsoft.com/office/mac/drawingml/2011/main" val="0"/>
+            </a:ext>
+          </a:extLst>
+        </p:spPr>
+        <p:txBody>
+          <a:bodyPr/>
+          <a:lstStyle>
+            <a:lvl1pPr>
+              <a:defRPr sz="1000">
+                <a:solidFill>
+                  <a:srgbClr val="5C6F7B"/>
+                </a:solidFill>
+              </a:defRPr>
+            </a:lvl1pPr>
+          </a:lstStyle>
+          <a:p>
+            <a:pPr algn="r"/>
+            <a:fld id="{F7021451-1387-4CA6-816F-3879F97B5CBC}" type="slidenum">
+              <a:rPr b="0" lang="en-US"/>
+              <a:t>14</a:t>
+            </a:fld>
+            <a:endParaRPr lang="en-US"/>
+          </a:p>
+        </p:txBody>
+      </p:sp>
+    </p:spTree>
+  </p:cSld>
+  <p:clrMapOvr>
+    <a:masterClrMapping/>
+  </p:clrMapOvr>
+</p:sld>
+</file>
+
+<file path=ppt/slides/slide15.xml><?xml version="1.0" encoding="utf-8"?>
+<p:sld xmlns:a="http://schemas.openxmlformats.org/drawingml/2006/main" xmlns:r="http://schemas.openxmlformats.org/officeDocument/2006/relationships" xmlns:p="http://schemas.openxmlformats.org/presentationml/2006/main">
+  <p:cSld name="Slide 15">
     <p:spTree>
       <p:nvGrpSpPr>
         <p:cNvPr id="1" name=""/>

</xml_diff>

<commit_message>
L1: slide complete con il fork
Co-Authored-By: Claude Opus 5.5 <noreply@anthropic.com>
Claude-Session: https://claude.ai/code/session_014CzWDFXvYNxqLeD99LSN3G
</commit_message>
<xml_diff>
--- a/L01_python_calcolatrice/slide_complete.pptx
+++ b/L01_python_calcolatrice/slide_complete.pptx
@@ -20,9 +20,10 @@
     <p:sldId id="268" r:id="rId14"/>
     <p:sldId id="269" r:id="rId15"/>
     <p:sldId id="270" r:id="rId16"/>
+    <p:sldId id="271" r:id="rId17"/>
   </p:sldIdLst>
   <p:notesMasterIdLst>
-    <p:notesMasterId r:id="rId17"/>
+    <p:notesMasterId r:id="rId18"/>
   </p:notesMasterIdLst>
   <p:sldSz cx="12192000" cy="6858000"/>
   <p:notesSz cx="6858000" cy="12192000"/>
@@ -121,13 +122,13 @@
   <p:extLst>
     <p:ext uri="{521415D9-36F7-43E2-AB2F-B90AF26B5E84}">
       <p14:sectionLst xmlns:p14="http://schemas.microsoft.com/office/powerpoint/2010/main">
-        <p14:section name="Apertura" id="{6cd74bd4-a3aa-3733-d989-3bc8ec6e1f5d}">
+        <p14:section name="Apertura" id="{fdc76b16-99bb-ff74-02c2-f58930e9fe13}">
           <p14:sldIdLst>
             <p14:sldId id="256"/>
             <p14:sldId id="257"/>
           </p14:sldIdLst>
         </p14:section>
-        <p14:section name="Spiegazione" id="{35d3c0de-c446-ebcb-a356-2fd13233009f}">
+        <p14:section name="Spiegazione" id="{dd4613c8-84ff-4a2b-a8f2-782a93dd4b12}">
           <p14:sldIdLst>
             <p14:sldId id="258"/>
             <p14:sldId id="259"/>
@@ -136,12 +137,12 @@
             <p14:sldId id="262"/>
           </p14:sldIdLst>
         </p14:section>
-        <p14:section name="Task" id="{24f44e97-6b2c-65ef-3e7d-a594b4e581d4}">
+        <p14:section name="Task" id="{52fda5e4-61e3-c4aa-bee4-03e9613bf9c6}">
           <p14:sldIdLst>
             <p14:sldId id="263"/>
           </p14:sldIdLst>
         </p14:section>
-        <p14:section name="Debrief" id="{86f19fdd-8797-748b-18e4-e2b62056a455}">
+        <p14:section name="Debrief" id="{1cc7048b-8f62-4dbc-04bf-af8efd2dc040}">
           <p14:sldIdLst>
             <p14:sldId id="264"/>
             <p14:sldId id="265"/>
@@ -151,9 +152,14 @@
             <p14:sldId id="269"/>
           </p14:sldIdLst>
         </p14:section>
-        <p14:section name="Chiusura" id="{a2031043-637a-5a0e-5c40-755637e91ed2}">
+        <p14:section name="Extra" id="{febb1f9a-24f2-9ae8-5fd8-305592da5e2b}">
           <p14:sldIdLst>
             <p14:sldId id="270"/>
+          </p14:sldIdLst>
+        </p14:section>
+        <p14:section name="Chiusura" id="{499da31e-8d86-db2a-d4d6-48cccb204d44}">
+          <p14:sldIdLst>
+            <p14:sldId id="271"/>
           </p14:sldIdLst>
         </p14:section>
       </p14:sectionLst>
@@ -1088,7 +1094,7 @@
           <a:p>
             <a:r>
               <a:rPr lang="en-US" dirty="0"/>
-              <a:t>Il problema dei tipi tornerà con l'Excel. Ricordare di creare l'account Kaggle.</a:t>
+              <a:t>Facoltativo: chi non vuole un account GitHub può continuare a salvare su Drive. Il fork è utile anche dopo il corso, come archivio personale del proprio lavoro. Di default il fork copia solo il branch principale, quindi niente soluzioni: vanno lette dal link nel README.</a:t>
             </a:r>
             <a:endParaRPr lang="en-US" dirty="0"/>
           </a:p>
@@ -1112,6 +1118,94 @@
             <a:fld id="{F7021451-1387-4CA6-816F-3879F97B5CBC}" type="slidenum">
               <a:rPr lang="en-US"/>
               <a:t>15</a:t>
+            </a:fld>
+            <a:endParaRPr lang="en-US"/>
+          </a:p>
+        </p:txBody>
+      </p:sp>
+    </p:spTree>
+    <p:extLst>
+      <p:ext uri="{BB962C8B-B14F-4D97-AF65-F5344CB8AC3E}">
+        <p14:creationId xmlns:p14="http://schemas.microsoft.com/office/powerpoint/2010/main" val="1024086991"/>
+      </p:ext>
+    </p:extLst>
+  </p:cSld>
+  <p:clrMapOvr>
+    <a:masterClrMapping/>
+  </p:clrMapOvr>
+</p:notes>
+</file>
+
+<file path=ppt/notesSlides/notesSlide16.xml><?xml version="1.0" encoding="utf-8"?>
+<p:notes xmlns:a="http://schemas.openxmlformats.org/drawingml/2006/main" xmlns:r="http://schemas.openxmlformats.org/officeDocument/2006/relationships" xmlns:p="http://schemas.openxmlformats.org/presentationml/2006/main">
+  <p:cSld>
+    <p:spTree>
+      <p:nvGrpSpPr>
+        <p:cNvPr id="1" name=""/>
+        <p:cNvGrpSpPr/>
+        <p:nvPr/>
+      </p:nvGrpSpPr>
+      <p:grpSpPr>
+        <a:xfrm>
+          <a:off x="0" y="0"/>
+          <a:ext cx="0" cy="0"/>
+          <a:chOff x="0" y="0"/>
+          <a:chExt cx="0" cy="0"/>
+        </a:xfrm>
+      </p:grpSpPr>
+      <p:sp>
+        <p:nvSpPr>
+          <p:cNvPr id="2" name="Slide Image Placeholder 1"/>
+          <p:cNvSpPr>
+            <a:spLocks noGrp="1" noRot="1" noChangeAspect="1"/>
+          </p:cNvSpPr>
+          <p:nvPr>
+            <p:ph type="sldImg"/>
+          </p:nvPr>
+        </p:nvSpPr>
+        <p:spPr/>
+      </p:sp>
+      <p:sp>
+        <p:nvSpPr>
+          <p:cNvPr id="3" name="Notes Placeholder 2"/>
+          <p:cNvSpPr>
+            <a:spLocks noGrp="1"/>
+          </p:cNvSpPr>
+          <p:nvPr>
+            <p:ph type="body" idx="1"/>
+          </p:nvPr>
+        </p:nvSpPr>
+        <p:spPr/>
+        <p:txBody>
+          <a:bodyPr/>
+          <a:lstStyle/>
+          <a:p>
+            <a:r>
+              <a:rPr lang="en-US" dirty="0"/>
+              <a:t>Il problema dei tipi tornerà con l'Excel. Ricordare di creare l'account Kaggle.</a:t>
+            </a:r>
+            <a:endParaRPr lang="en-US" dirty="0"/>
+          </a:p>
+        </p:txBody>
+      </p:sp>
+      <p:sp>
+        <p:nvSpPr>
+          <p:cNvPr id="4" name="Slide Number Placeholder 3"/>
+          <p:cNvSpPr>
+            <a:spLocks noGrp="1"/>
+          </p:cNvSpPr>
+          <p:nvPr>
+            <p:ph type="sldNum" sz="quarter" idx="10"/>
+          </p:nvPr>
+        </p:nvSpPr>
+        <p:spPr/>
+        <p:txBody>
+          <a:bodyPr/>
+          <a:lstStyle/>
+          <a:p>
+            <a:fld id="{F7021451-1387-4CA6-816F-3879F97B5CBC}" type="slidenum">
+              <a:rPr lang="en-US"/>
+              <a:t>16</a:t>
             </a:fld>
             <a:endParaRPr lang="en-US"/>
           </a:p>
@@ -5883,6 +5977,790 @@
         </p:nvSpPr>
         <p:spPr>
           <a:xfrm>
+            <a:off x="548640" y="365760"/>
+            <a:ext cx="11064240" cy="822960"/>
+          </a:xfrm>
+          <a:prstGeom prst="rect">
+            <a:avLst/>
+          </a:prstGeom>
+          <a:noFill/>
+          <a:ln/>
+        </p:spPr>
+        <p:txBody>
+          <a:bodyPr wrap="square" lIns="0" tIns="0" rIns="0" bIns="0" rtlCol="0" anchor="ctr"/>
+          <a:lstStyle/>
+          <a:p>
+            <a:pPr algn="l" indent="0" marL="0">
+              <a:buNone/>
+            </a:pPr>
+            <a:r>
+              <a:rPr lang="en-US" sz="3600" b="1" dirty="0">
+                <a:solidFill>
+                  <a:srgbClr val="0F4C5C"/>
+                </a:solidFill>
+              </a:rPr>
+              <a:t>Extra: una copia del corso tutta tua</a:t>
+            </a:r>
+            <a:endParaRPr lang="en-US" sz="3600" dirty="0"/>
+          </a:p>
+        </p:txBody>
+      </p:sp>
+      <p:sp>
+        <p:nvSpPr>
+          <p:cNvPr id="3" name="Shape 1"/>
+          <p:cNvSpPr/>
+          <p:nvPr/>
+        </p:nvSpPr>
+        <p:spPr>
+          <a:xfrm>
+            <a:off x="548640" y="1737360"/>
+            <a:ext cx="2606040" cy="2194560"/>
+          </a:xfrm>
+          <a:prstGeom prst="roundRect">
+            <a:avLst>
+              <a:gd name="adj" fmla="val 5000"/>
+            </a:avLst>
+          </a:prstGeom>
+          <a:solidFill>
+            <a:srgbClr val="EEF3F4"/>
+          </a:solidFill>
+          <a:ln/>
+        </p:spPr>
+      </p:sp>
+      <p:sp>
+        <p:nvSpPr>
+          <p:cNvPr id="4" name="Shape 2"/>
+          <p:cNvSpPr/>
+          <p:nvPr/>
+        </p:nvSpPr>
+        <p:spPr>
+          <a:xfrm>
+            <a:off x="822960" y="2011680"/>
+            <a:ext cx="640080" cy="640080"/>
+          </a:xfrm>
+          <a:prstGeom prst="ellipse">
+            <a:avLst/>
+          </a:prstGeom>
+          <a:solidFill>
+            <a:srgbClr val="E09F3E"/>
+          </a:solidFill>
+          <a:ln/>
+        </p:spPr>
+      </p:sp>
+      <p:sp>
+        <p:nvSpPr>
+          <p:cNvPr id="5" name="Text 3"/>
+          <p:cNvSpPr txBox="1"/>
+          <p:nvPr/>
+        </p:nvSpPr>
+        <p:spPr>
+          <a:xfrm>
+            <a:off x="822960" y="2011680"/>
+            <a:ext cx="640080" cy="640080"/>
+          </a:xfrm>
+          <a:prstGeom prst="rect">
+            <a:avLst/>
+          </a:prstGeom>
+          <a:noFill/>
+          <a:ln/>
+        </p:spPr>
+        <p:txBody>
+          <a:bodyPr wrap="square" lIns="0" tIns="0" rIns="0" bIns="0" rtlCol="0" anchor="ctr"/>
+          <a:lstStyle/>
+          <a:p>
+            <a:pPr algn="ctr" indent="0" marL="0">
+              <a:buNone/>
+            </a:pPr>
+            <a:r>
+              <a:rPr lang="en-US" sz="1820" b="1" dirty="0">
+                <a:solidFill>
+                  <a:srgbClr val="1F2A30"/>
+                </a:solidFill>
+              </a:rPr>
+              <a:t>1</a:t>
+            </a:r>
+            <a:endParaRPr lang="en-US" sz="1820" dirty="0"/>
+          </a:p>
+        </p:txBody>
+      </p:sp>
+      <p:sp>
+        <p:nvSpPr>
+          <p:cNvPr id="6" name="Text 4"/>
+          <p:cNvSpPr txBox="1"/>
+          <p:nvPr/>
+        </p:nvSpPr>
+        <p:spPr>
+          <a:xfrm>
+            <a:off x="822960" y="2788920"/>
+            <a:ext cx="2148840" cy="457200"/>
+          </a:xfrm>
+          <a:prstGeom prst="rect">
+            <a:avLst/>
+          </a:prstGeom>
+          <a:noFill/>
+          <a:ln/>
+        </p:spPr>
+        <p:txBody>
+          <a:bodyPr wrap="square" lIns="0" tIns="0" rIns="0" bIns="0" rtlCol="0" anchor="ctr"/>
+          <a:lstStyle/>
+          <a:p>
+            <a:pPr indent="0" marL="0">
+              <a:buNone/>
+            </a:pPr>
+            <a:r>
+              <a:rPr lang="en-US" sz="1900" b="1" dirty="0">
+                <a:solidFill>
+                  <a:srgbClr val="1F2A30"/>
+                </a:solidFill>
+              </a:rPr>
+              <a:t>Crea un account</a:t>
+            </a:r>
+            <a:endParaRPr lang="en-US" sz="1900" dirty="0"/>
+          </a:p>
+        </p:txBody>
+      </p:sp>
+      <p:sp>
+        <p:nvSpPr>
+          <p:cNvPr id="7" name="Text 5"/>
+          <p:cNvSpPr txBox="1"/>
+          <p:nvPr/>
+        </p:nvSpPr>
+        <p:spPr>
+          <a:xfrm>
+            <a:off x="822960" y="3246120"/>
+            <a:ext cx="2148840" cy="594360"/>
+          </a:xfrm>
+          <a:prstGeom prst="rect">
+            <a:avLst/>
+          </a:prstGeom>
+          <a:noFill/>
+          <a:ln/>
+        </p:spPr>
+        <p:txBody>
+          <a:bodyPr wrap="square" lIns="0" tIns="0" rIns="0" bIns="0" rtlCol="0" anchor="t"/>
+          <a:lstStyle/>
+          <a:p>
+            <a:pPr indent="0" marL="0">
+              <a:buNone/>
+            </a:pPr>
+            <a:r>
+              <a:rPr lang="en-US" sz="1300" dirty="0">
+                <a:solidFill>
+                  <a:srgbClr val="5C6F7B"/>
+                </a:solidFill>
+              </a:rPr>
+              <a:t>su github.com, gratuito</a:t>
+            </a:r>
+            <a:endParaRPr lang="en-US" sz="1300" dirty="0"/>
+          </a:p>
+        </p:txBody>
+      </p:sp>
+      <p:sp>
+        <p:nvSpPr>
+          <p:cNvPr id="8" name="Shape 6"/>
+          <p:cNvSpPr/>
+          <p:nvPr/>
+        </p:nvSpPr>
+        <p:spPr>
+          <a:xfrm>
+            <a:off x="3383280" y="1737360"/>
+            <a:ext cx="2606040" cy="2194560"/>
+          </a:xfrm>
+          <a:prstGeom prst="roundRect">
+            <a:avLst>
+              <a:gd name="adj" fmla="val 5000"/>
+            </a:avLst>
+          </a:prstGeom>
+          <a:solidFill>
+            <a:srgbClr val="EEF3F4"/>
+          </a:solidFill>
+          <a:ln/>
+        </p:spPr>
+      </p:sp>
+      <p:sp>
+        <p:nvSpPr>
+          <p:cNvPr id="9" name="Shape 7"/>
+          <p:cNvSpPr/>
+          <p:nvPr/>
+        </p:nvSpPr>
+        <p:spPr>
+          <a:xfrm>
+            <a:off x="3657600" y="2011680"/>
+            <a:ext cx="640080" cy="640080"/>
+          </a:xfrm>
+          <a:prstGeom prst="ellipse">
+            <a:avLst/>
+          </a:prstGeom>
+          <a:solidFill>
+            <a:srgbClr val="E09F3E"/>
+          </a:solidFill>
+          <a:ln/>
+        </p:spPr>
+      </p:sp>
+      <p:sp>
+        <p:nvSpPr>
+          <p:cNvPr id="10" name="Text 8"/>
+          <p:cNvSpPr txBox="1"/>
+          <p:nvPr/>
+        </p:nvSpPr>
+        <p:spPr>
+          <a:xfrm>
+            <a:off x="3657600" y="2011680"/>
+            <a:ext cx="640080" cy="640080"/>
+          </a:xfrm>
+          <a:prstGeom prst="rect">
+            <a:avLst/>
+          </a:prstGeom>
+          <a:noFill/>
+          <a:ln/>
+        </p:spPr>
+        <p:txBody>
+          <a:bodyPr wrap="square" lIns="0" tIns="0" rIns="0" bIns="0" rtlCol="0" anchor="ctr"/>
+          <a:lstStyle/>
+          <a:p>
+            <a:pPr algn="ctr" indent="0" marL="0">
+              <a:buNone/>
+            </a:pPr>
+            <a:r>
+              <a:rPr lang="en-US" sz="1820" b="1" dirty="0">
+                <a:solidFill>
+                  <a:srgbClr val="1F2A30"/>
+                </a:solidFill>
+              </a:rPr>
+              <a:t>2</a:t>
+            </a:r>
+            <a:endParaRPr lang="en-US" sz="1820" dirty="0"/>
+          </a:p>
+        </p:txBody>
+      </p:sp>
+      <p:sp>
+        <p:nvSpPr>
+          <p:cNvPr id="11" name="Text 9"/>
+          <p:cNvSpPr txBox="1"/>
+          <p:nvPr/>
+        </p:nvSpPr>
+        <p:spPr>
+          <a:xfrm>
+            <a:off x="3657600" y="2788920"/>
+            <a:ext cx="2148840" cy="457200"/>
+          </a:xfrm>
+          <a:prstGeom prst="rect">
+            <a:avLst/>
+          </a:prstGeom>
+          <a:noFill/>
+          <a:ln/>
+        </p:spPr>
+        <p:txBody>
+          <a:bodyPr wrap="square" lIns="0" tIns="0" rIns="0" bIns="0" rtlCol="0" anchor="ctr"/>
+          <a:lstStyle/>
+          <a:p>
+            <a:pPr indent="0" marL="0">
+              <a:buNone/>
+            </a:pPr>
+            <a:r>
+              <a:rPr lang="en-US" sz="1900" b="1" dirty="0">
+                <a:solidFill>
+                  <a:srgbClr val="1F2A30"/>
+                </a:solidFill>
+              </a:rPr>
+              <a:t>Apri il repository</a:t>
+            </a:r>
+            <a:endParaRPr lang="en-US" sz="1900" dirty="0"/>
+          </a:p>
+        </p:txBody>
+      </p:sp>
+      <p:sp>
+        <p:nvSpPr>
+          <p:cNvPr id="12" name="Text 10"/>
+          <p:cNvSpPr txBox="1"/>
+          <p:nvPr/>
+        </p:nvSpPr>
+        <p:spPr>
+          <a:xfrm>
+            <a:off x="3657600" y="3246120"/>
+            <a:ext cx="2148840" cy="594360"/>
+          </a:xfrm>
+          <a:prstGeom prst="rect">
+            <a:avLst/>
+          </a:prstGeom>
+          <a:noFill/>
+          <a:ln/>
+        </p:spPr>
+        <p:txBody>
+          <a:bodyPr wrap="square" lIns="0" tIns="0" rIns="0" bIns="0" rtlCol="0" anchor="t"/>
+          <a:lstStyle/>
+          <a:p>
+            <a:pPr indent="0" marL="0">
+              <a:buNone/>
+            </a:pPr>
+            <a:r>
+              <a:rPr lang="en-US" sz="1300" dirty="0">
+                <a:solidFill>
+                  <a:srgbClr val="5C6F7B"/>
+                </a:solidFill>
+              </a:rPr>
+              <a:t>github.com/andrealorenzon/SIMA2026</a:t>
+            </a:r>
+            <a:endParaRPr lang="en-US" sz="1300" dirty="0"/>
+          </a:p>
+        </p:txBody>
+      </p:sp>
+      <p:sp>
+        <p:nvSpPr>
+          <p:cNvPr id="13" name="Shape 11"/>
+          <p:cNvSpPr/>
+          <p:nvPr/>
+        </p:nvSpPr>
+        <p:spPr>
+          <a:xfrm>
+            <a:off x="6217920" y="1737360"/>
+            <a:ext cx="2606040" cy="2194560"/>
+          </a:xfrm>
+          <a:prstGeom prst="roundRect">
+            <a:avLst>
+              <a:gd name="adj" fmla="val 5000"/>
+            </a:avLst>
+          </a:prstGeom>
+          <a:solidFill>
+            <a:srgbClr val="EEF3F4"/>
+          </a:solidFill>
+          <a:ln/>
+        </p:spPr>
+      </p:sp>
+      <p:sp>
+        <p:nvSpPr>
+          <p:cNvPr id="14" name="Shape 12"/>
+          <p:cNvSpPr/>
+          <p:nvPr/>
+        </p:nvSpPr>
+        <p:spPr>
+          <a:xfrm>
+            <a:off x="6492240" y="2011680"/>
+            <a:ext cx="640080" cy="640080"/>
+          </a:xfrm>
+          <a:prstGeom prst="ellipse">
+            <a:avLst/>
+          </a:prstGeom>
+          <a:solidFill>
+            <a:srgbClr val="E09F3E"/>
+          </a:solidFill>
+          <a:ln/>
+        </p:spPr>
+      </p:sp>
+      <p:sp>
+        <p:nvSpPr>
+          <p:cNvPr id="15" name="Text 13"/>
+          <p:cNvSpPr txBox="1"/>
+          <p:nvPr/>
+        </p:nvSpPr>
+        <p:spPr>
+          <a:xfrm>
+            <a:off x="6492240" y="2011680"/>
+            <a:ext cx="640080" cy="640080"/>
+          </a:xfrm>
+          <a:prstGeom prst="rect">
+            <a:avLst/>
+          </a:prstGeom>
+          <a:noFill/>
+          <a:ln/>
+        </p:spPr>
+        <p:txBody>
+          <a:bodyPr wrap="square" lIns="0" tIns="0" rIns="0" bIns="0" rtlCol="0" anchor="ctr"/>
+          <a:lstStyle/>
+          <a:p>
+            <a:pPr algn="ctr" indent="0" marL="0">
+              <a:buNone/>
+            </a:pPr>
+            <a:r>
+              <a:rPr lang="en-US" sz="1820" b="1" dirty="0">
+                <a:solidFill>
+                  <a:srgbClr val="1F2A30"/>
+                </a:solidFill>
+              </a:rPr>
+              <a:t>3</a:t>
+            </a:r>
+            <a:endParaRPr lang="en-US" sz="1820" dirty="0"/>
+          </a:p>
+        </p:txBody>
+      </p:sp>
+      <p:sp>
+        <p:nvSpPr>
+          <p:cNvPr id="16" name="Text 14"/>
+          <p:cNvSpPr txBox="1"/>
+          <p:nvPr/>
+        </p:nvSpPr>
+        <p:spPr>
+          <a:xfrm>
+            <a:off x="6492240" y="2788920"/>
+            <a:ext cx="2148840" cy="457200"/>
+          </a:xfrm>
+          <a:prstGeom prst="rect">
+            <a:avLst/>
+          </a:prstGeom>
+          <a:noFill/>
+          <a:ln/>
+        </p:spPr>
+        <p:txBody>
+          <a:bodyPr wrap="square" lIns="0" tIns="0" rIns="0" bIns="0" rtlCol="0" anchor="ctr"/>
+          <a:lstStyle/>
+          <a:p>
+            <a:pPr indent="0" marL="0">
+              <a:buNone/>
+            </a:pPr>
+            <a:r>
+              <a:rPr lang="en-US" sz="1900" b="1" dirty="0">
+                <a:solidFill>
+                  <a:srgbClr val="1F2A30"/>
+                </a:solidFill>
+              </a:rPr>
+              <a:t>Clicca «Fork»</a:t>
+            </a:r>
+            <a:endParaRPr lang="en-US" sz="1900" dirty="0"/>
+          </a:p>
+        </p:txBody>
+      </p:sp>
+      <p:sp>
+        <p:nvSpPr>
+          <p:cNvPr id="17" name="Text 15"/>
+          <p:cNvSpPr txBox="1"/>
+          <p:nvPr/>
+        </p:nvSpPr>
+        <p:spPr>
+          <a:xfrm>
+            <a:off x="6492240" y="3246120"/>
+            <a:ext cx="2148840" cy="594360"/>
+          </a:xfrm>
+          <a:prstGeom prst="rect">
+            <a:avLst/>
+          </a:prstGeom>
+          <a:noFill/>
+          <a:ln/>
+        </p:spPr>
+        <p:txBody>
+          <a:bodyPr wrap="square" lIns="0" tIns="0" rIns="0" bIns="0" rtlCol="0" anchor="t"/>
+          <a:lstStyle/>
+          <a:p>
+            <a:pPr indent="0" marL="0">
+              <a:buNone/>
+            </a:pPr>
+            <a:r>
+              <a:rPr lang="en-US" sz="1300" dirty="0">
+                <a:solidFill>
+                  <a:srgbClr val="5C6F7B"/>
+                </a:solidFill>
+              </a:rPr>
+              <a:t>in alto a destra, poi «Create fork»</a:t>
+            </a:r>
+            <a:endParaRPr lang="en-US" sz="1300" dirty="0"/>
+          </a:p>
+        </p:txBody>
+      </p:sp>
+      <p:sp>
+        <p:nvSpPr>
+          <p:cNvPr id="18" name="Shape 16"/>
+          <p:cNvSpPr/>
+          <p:nvPr/>
+        </p:nvSpPr>
+        <p:spPr>
+          <a:xfrm>
+            <a:off x="9052560" y="1737360"/>
+            <a:ext cx="2606040" cy="2194560"/>
+          </a:xfrm>
+          <a:prstGeom prst="roundRect">
+            <a:avLst>
+              <a:gd name="adj" fmla="val 5000"/>
+            </a:avLst>
+          </a:prstGeom>
+          <a:solidFill>
+            <a:srgbClr val="0F4C5C"/>
+          </a:solidFill>
+          <a:ln/>
+        </p:spPr>
+      </p:sp>
+      <p:sp>
+        <p:nvSpPr>
+          <p:cNvPr id="19" name="Shape 17"/>
+          <p:cNvSpPr/>
+          <p:nvPr/>
+        </p:nvSpPr>
+        <p:spPr>
+          <a:xfrm>
+            <a:off x="9326880" y="2011680"/>
+            <a:ext cx="640080" cy="640080"/>
+          </a:xfrm>
+          <a:prstGeom prst="ellipse">
+            <a:avLst/>
+          </a:prstGeom>
+          <a:solidFill>
+            <a:srgbClr val="E09F3E"/>
+          </a:solidFill>
+          <a:ln/>
+        </p:spPr>
+      </p:sp>
+      <p:sp>
+        <p:nvSpPr>
+          <p:cNvPr id="20" name="Text 18"/>
+          <p:cNvSpPr txBox="1"/>
+          <p:nvPr/>
+        </p:nvSpPr>
+        <p:spPr>
+          <a:xfrm>
+            <a:off x="9326880" y="2011680"/>
+            <a:ext cx="640080" cy="640080"/>
+          </a:xfrm>
+          <a:prstGeom prst="rect">
+            <a:avLst/>
+          </a:prstGeom>
+          <a:noFill/>
+          <a:ln/>
+        </p:spPr>
+        <p:txBody>
+          <a:bodyPr wrap="square" lIns="0" tIns="0" rIns="0" bIns="0" rtlCol="0" anchor="ctr"/>
+          <a:lstStyle/>
+          <a:p>
+            <a:pPr algn="ctr" indent="0" marL="0">
+              <a:buNone/>
+            </a:pPr>
+            <a:r>
+              <a:rPr lang="en-US" sz="1820" b="1" dirty="0">
+                <a:solidFill>
+                  <a:srgbClr val="1F2A30"/>
+                </a:solidFill>
+              </a:rPr>
+              <a:t>4</a:t>
+            </a:r>
+            <a:endParaRPr lang="en-US" sz="1820" dirty="0"/>
+          </a:p>
+        </p:txBody>
+      </p:sp>
+      <p:sp>
+        <p:nvSpPr>
+          <p:cNvPr id="21" name="Text 19"/>
+          <p:cNvSpPr txBox="1"/>
+          <p:nvPr/>
+        </p:nvSpPr>
+        <p:spPr>
+          <a:xfrm>
+            <a:off x="9326880" y="2788920"/>
+            <a:ext cx="2148840" cy="457200"/>
+          </a:xfrm>
+          <a:prstGeom prst="rect">
+            <a:avLst/>
+          </a:prstGeom>
+          <a:noFill/>
+          <a:ln/>
+        </p:spPr>
+        <p:txBody>
+          <a:bodyPr wrap="square" lIns="0" tIns="0" rIns="0" bIns="0" rtlCol="0" anchor="ctr"/>
+          <a:lstStyle/>
+          <a:p>
+            <a:pPr indent="0" marL="0">
+              <a:buNone/>
+            </a:pPr>
+            <a:r>
+              <a:rPr lang="en-US" sz="1900" b="1" dirty="0">
+                <a:solidFill>
+                  <a:srgbClr val="FFFFFF"/>
+                </a:solidFill>
+              </a:rPr>
+              <a:t>È tuo</a:t>
+            </a:r>
+            <a:endParaRPr lang="en-US" sz="1900" dirty="0"/>
+          </a:p>
+        </p:txBody>
+      </p:sp>
+      <p:sp>
+        <p:nvSpPr>
+          <p:cNvPr id="22" name="Text 20"/>
+          <p:cNvSpPr txBox="1"/>
+          <p:nvPr/>
+        </p:nvSpPr>
+        <p:spPr>
+          <a:xfrm>
+            <a:off x="9326880" y="3246120"/>
+            <a:ext cx="2148840" cy="594360"/>
+          </a:xfrm>
+          <a:prstGeom prst="rect">
+            <a:avLst/>
+          </a:prstGeom>
+          <a:noFill/>
+          <a:ln/>
+        </p:spPr>
+        <p:txBody>
+          <a:bodyPr wrap="square" lIns="0" tIns="0" rIns="0" bIns="0" rtlCol="0" anchor="t"/>
+          <a:lstStyle/>
+          <a:p>
+            <a:pPr indent="0" marL="0">
+              <a:buNone/>
+            </a:pPr>
+            <a:r>
+              <a:rPr lang="en-US" sz="1300" dirty="0">
+                <a:solidFill>
+                  <a:srgbClr val="B8C4CB"/>
+                </a:solidFill>
+              </a:rPr>
+              <a:t>github.com/&lt;tuo-nome&gt;/SIMA2026</a:t>
+            </a:r>
+            <a:endParaRPr lang="en-US" sz="1300" dirty="0"/>
+          </a:p>
+        </p:txBody>
+      </p:sp>
+      <p:sp>
+        <p:nvSpPr>
+          <p:cNvPr id="23" name="Text 21"/>
+          <p:cNvSpPr txBox="1"/>
+          <p:nvPr/>
+        </p:nvSpPr>
+        <p:spPr>
+          <a:xfrm>
+            <a:off x="548640" y="4251960"/>
+            <a:ext cx="11064240" cy="1554480"/>
+          </a:xfrm>
+          <a:prstGeom prst="rect">
+            <a:avLst/>
+          </a:prstGeom>
+          <a:noFill/>
+          <a:ln/>
+        </p:spPr>
+        <p:txBody>
+          <a:bodyPr wrap="square" lIns="0" tIns="0" rIns="0" bIns="0" rtlCol="0" anchor="t"/>
+          <a:lstStyle/>
+          <a:p>
+            <a:pPr marL="342900" indent="-342900">
+              <a:spcAft>
+                <a:spcPts val="1000"/>
+              </a:spcAft>
+              <a:buSzPct val="100000"/>
+              <a:buChar char="•"/>
+            </a:pPr>
+            <a:r>
+              <a:rPr lang="en-US" sz="1700" dirty="0">
+                <a:solidFill>
+                  <a:srgbClr val="1F2A30"/>
+                </a:solidFill>
+              </a:rPr>
+              <a:t>Un fork è una copia del repository nel tuo account: puoi modificarla senza toccare l'originale.</a:t>
+            </a:r>
+            <a:endParaRPr lang="en-US" sz="1700" dirty="0"/>
+          </a:p>
+          <a:p>
+            <a:pPr marL="342900" indent="-342900">
+              <a:spcAft>
+                <a:spcPts val="1000"/>
+              </a:spcAft>
+              <a:buSzPct val="100000"/>
+              <a:buChar char="•"/>
+            </a:pPr>
+            <a:r>
+              <a:rPr lang="en-US" sz="1700" dirty="0">
+                <a:solidFill>
+                  <a:srgbClr val="1F2A30"/>
+                </a:solidFill>
+              </a:rPr>
+              <a:t>Da Colab salvi i notebook direttamente lì: File → Salva una copia in GitHub.</a:t>
+            </a:r>
+            <a:endParaRPr lang="en-US" sz="1700" dirty="0"/>
+          </a:p>
+          <a:p>
+            <a:pPr marL="342900" indent="-342900">
+              <a:spcAft>
+                <a:spcPts val="1000"/>
+              </a:spcAft>
+              <a:buSzPct val="100000"/>
+              <a:buChar char="•"/>
+            </a:pPr>
+            <a:r>
+              <a:rPr lang="en-US" sz="1700" dirty="0">
+                <a:solidFill>
+                  <a:srgbClr val="1F2A30"/>
+                </a:solidFill>
+              </a:rPr>
+              <a:t>Quando il corso si aggiorna, sul tuo fork clicca «Sync fork» per ricevere le novità.</a:t>
+            </a:r>
+            <a:endParaRPr lang="en-US" sz="1700" dirty="0"/>
+          </a:p>
+        </p:txBody>
+      </p:sp>
+      <p:sp>
+        <p:nvSpPr>
+          <p:cNvPr id="25" name="Slide Number Placeholder 0"/>
+          <p:cNvSpPr>
+            <a:spLocks noGrp="1"/>
+          </p:cNvSpPr>
+          <p:nvPr>
+            <p:ph type="sldNum" sz="quarter" idx="4294967295"/>
+          </p:nvPr>
+        </p:nvSpPr>
+        <p:spPr>
+          <a:xfrm>
+            <a:off x="11155680" y="6400800"/>
+            <a:ext cx="457200" cy="274320"/>
+          </a:xfrm>
+          <a:prstGeom prst="rect">
+            <a:avLst/>
+          </a:prstGeom>
+          <a:extLst>
+            <a:ext uri="{C572A759-6A51-4108-AA02-DFA0A04FC94B}">
+              <ma14:wrappingTextBoxFlag xmlns:ma14="http://schemas.microsoft.com/office/mac/drawingml/2011/main" val="0"/>
+            </a:ext>
+          </a:extLst>
+        </p:spPr>
+        <p:txBody>
+          <a:bodyPr/>
+          <a:lstStyle>
+            <a:lvl1pPr>
+              <a:defRPr sz="1000">
+                <a:solidFill>
+                  <a:srgbClr val="5C6F7B"/>
+                </a:solidFill>
+              </a:defRPr>
+            </a:lvl1pPr>
+          </a:lstStyle>
+          <a:p>
+            <a:pPr algn="r"/>
+            <a:fld id="{F7021451-1387-4CA6-816F-3879F97B5CBC}" type="slidenum">
+              <a:rPr b="0" lang="en-US"/>
+              <a:t>15</a:t>
+            </a:fld>
+            <a:endParaRPr lang="en-US"/>
+          </a:p>
+        </p:txBody>
+      </p:sp>
+    </p:spTree>
+  </p:cSld>
+  <p:clrMapOvr>
+    <a:masterClrMapping/>
+  </p:clrMapOvr>
+</p:sld>
+</file>
+
+<file path=ppt/slides/slide16.xml><?xml version="1.0" encoding="utf-8"?>
+<p:sld xmlns:a="http://schemas.openxmlformats.org/drawingml/2006/main" xmlns:r="http://schemas.openxmlformats.org/officeDocument/2006/relationships" xmlns:p="http://schemas.openxmlformats.org/presentationml/2006/main">
+  <p:cSld name="Slide 16">
+    <p:spTree>
+      <p:nvGrpSpPr>
+        <p:cNvPr id="1" name=""/>
+        <p:cNvGrpSpPr/>
+        <p:nvPr/>
+      </p:nvGrpSpPr>
+      <p:grpSpPr>
+        <a:xfrm>
+          <a:off x="0" y="0"/>
+          <a:ext cx="0" cy="0"/>
+          <a:chOff x="0" y="0"/>
+          <a:chExt cx="0" cy="0"/>
+        </a:xfrm>
+      </p:grpSpPr>
+      <p:sp>
+        <p:nvSpPr>
+          <p:cNvPr id="2" name="Text 0"/>
+          <p:cNvSpPr/>
+          <p:nvPr>
+            <p:ph idx="100" type="title" hasCustomPrompt="1"/>
+          </p:nvPr>
+        </p:nvSpPr>
+        <p:spPr>
+          <a:xfrm>
             <a:off x="731520" y="2103120"/>
             <a:ext cx="10698480" cy="1463040"/>
           </a:xfrm>

</xml_diff>

<commit_message>
Soluzioni e slide complete allineate alla revisione dei prerequisiti
Co-Authored-By: Claude Opus 5.5 <noreply@anthropic.com>
Claude-Session: https://claude.ai/code/session_014CzWDFXvYNxqLeD99LSN3G
</commit_message>
<xml_diff>
--- a/L01_python_calcolatrice/slide_complete.pptx
+++ b/L01_python_calcolatrice/slide_complete.pptx
@@ -123,13 +123,13 @@
   <p:extLst>
     <p:ext uri="{521415D9-36F7-43E2-AB2F-B90AF26B5E84}">
       <p14:sectionLst xmlns:p14="http://schemas.microsoft.com/office/powerpoint/2010/main">
-        <p14:section name="Apertura" id="{b237d209-b773-c06b-1e13-cf7ed29db3e1}">
+        <p14:section name="Apertura" id="{56f8561c-4012-4dfa-870f-848b380f4ceb}">
           <p14:sldIdLst>
             <p14:sldId id="256"/>
             <p14:sldId id="257"/>
           </p14:sldIdLst>
         </p14:section>
-        <p14:section name="Spiegazione" id="{0e5cece5-0800-f8d1-0300-8953822e2f9c}">
+        <p14:section name="Spiegazione" id="{1a71c95f-d0f6-5f89-aa05-cce52df65755}">
           <p14:sldIdLst>
             <p14:sldId id="258"/>
             <p14:sldId id="259"/>
@@ -139,12 +139,12 @@
             <p14:sldId id="263"/>
           </p14:sldIdLst>
         </p14:section>
-        <p14:section name="Task" id="{d185cb90-9993-8eda-a609-fcac0c8dc4e8}">
+        <p14:section name="Task" id="{f5e77d71-54c1-7d20-5494-60ea3883bb98}">
           <p14:sldIdLst>
             <p14:sldId id="264"/>
           </p14:sldIdLst>
         </p14:section>
-        <p14:section name="Debrief" id="{8214c56d-9a54-0323-c164-8e49c3670c5b}">
+        <p14:section name="Debrief" id="{4c989b74-ab18-3404-8f67-cf9503c9da5e}">
           <p14:sldIdLst>
             <p14:sldId id="265"/>
             <p14:sldId id="266"/>
@@ -154,12 +154,12 @@
             <p14:sldId id="270"/>
           </p14:sldIdLst>
         </p14:section>
-        <p14:section name="Extra" id="{70453769-e83a-6310-5a9d-531f836e2b39}">
+        <p14:section name="Extra" id="{6b050ad6-239d-72c9-2837-288bd7b58ded}">
           <p14:sldIdLst>
             <p14:sldId id="271"/>
           </p14:sldIdLst>
         </p14:section>
-        <p14:section name="Chiusura" id="{a16832b1-a33d-945f-2839-5230d32c503e}">
+        <p14:section name="Chiusura" id="{c65d09ad-8deb-b620-38dd-0921321bf7bc}">
           <p14:sldIdLst>
             <p14:sldId id="272"/>
           </p14:sldIdLst>
@@ -1888,7 +1888,7 @@
           <a:p>
             <a:r>
               <a:rPr lang="en-US" dirty="0"/>
-              <a:t>Su Zoom: stanze separate da 3. Comporre i gruppi mescolando chi ha già qualche esperienza (Stata, R, Excel avanzato) con chi parte da zero. Gruppi fissi per qualche settimana aiutano.</a:t>
+              <a:t>Su Zoom: stanze separate da 3. Comporre i gruppi mescolando chi ha già qualche esperienza (Stata, R, Excel avanzato) con chi parte da zero. Gruppi fissi per qualche settimana aiutano. Il codice sta nel notebook di chi scrive: per questo i ruoli ruotano a ogni incontro e non a ogni passo. A fine lezione chi ha scritto condivide il notebook con gli altri due.</a:t>
             </a:r>
             <a:endParaRPr lang="en-US" dirty="0"/>
           </a:p>
@@ -10819,7 +10819,7 @@
                   <a:srgbClr val="5C6F7B"/>
                 </a:solidFill>
               </a:rPr>
-              <a:t>condivide lo schermo e scrive il codice</a:t>
+              <a:t>condivide lo schermo e scrive il codice nel suo notebook</a:t>
             </a:r>
             <a:endParaRPr lang="en-US" sz="1600" dirty="0"/>
           </a:p>
@@ -11131,7 +11131,7 @@
                   <a:srgbClr val="0F4C5C"/>
                 </a:solidFill>
               </a:rPr>
-              <a:t>I ruoli ruotano a ogni passo. Il più importante è chi controlla: è il mestiere che il corso vuole allenare.</a:t>
+              <a:t>I ruoli ruotano a ogni incontro. Il più importante è chi controlla: è il mestiere che il corso vuole allenare.</a:t>
             </a:r>
             <a:endParaRPr lang="en-US" sz="1800" dirty="0"/>
           </a:p>

</xml_diff>

<commit_message>
Slide complete L1-L3: note per Zoom
Co-Authored-By: Claude Opus 5.5 <noreply@anthropic.com>
Claude-Session: https://claude.ai/code/session_014CzWDFXvYNxqLeD99LSN3G
</commit_message>
<xml_diff>
--- a/L01_python_calcolatrice/slide_complete.pptx
+++ b/L01_python_calcolatrice/slide_complete.pptx
@@ -123,13 +123,13 @@
   <p:extLst>
     <p:ext uri="{521415D9-36F7-43E2-AB2F-B90AF26B5E84}">
       <p14:sectionLst xmlns:p14="http://schemas.microsoft.com/office/powerpoint/2010/main">
-        <p14:section name="Apertura" id="{56f8561c-4012-4dfa-870f-848b380f4ceb}">
+        <p14:section name="Apertura" id="{056ad440-5ce1-fe8b-43b5-702aa5013282}">
           <p14:sldIdLst>
             <p14:sldId id="256"/>
             <p14:sldId id="257"/>
           </p14:sldIdLst>
         </p14:section>
-        <p14:section name="Spiegazione" id="{1a71c95f-d0f6-5f89-aa05-cce52df65755}">
+        <p14:section name="Spiegazione" id="{3e06705d-7761-4fd0-da1e-780cb958eb0f}">
           <p14:sldIdLst>
             <p14:sldId id="258"/>
             <p14:sldId id="259"/>
@@ -139,12 +139,12 @@
             <p14:sldId id="263"/>
           </p14:sldIdLst>
         </p14:section>
-        <p14:section name="Task" id="{f5e77d71-54c1-7d20-5494-60ea3883bb98}">
+        <p14:section name="Task" id="{0f4a2c04-5801-848e-a582-f4a361fc9ac5}">
           <p14:sldIdLst>
             <p14:sldId id="264"/>
           </p14:sldIdLst>
         </p14:section>
-        <p14:section name="Debrief" id="{4c989b74-ab18-3404-8f67-cf9503c9da5e}">
+        <p14:section name="Debrief" id="{a410796a-9f6a-c86d-b18f-1f7aa4e255a1}">
           <p14:sldIdLst>
             <p14:sldId id="265"/>
             <p14:sldId id="266"/>
@@ -154,12 +154,12 @@
             <p14:sldId id="270"/>
           </p14:sldIdLst>
         </p14:section>
-        <p14:section name="Extra" id="{6b050ad6-239d-72c9-2837-288bd7b58ded}">
+        <p14:section name="Extra" id="{db5f0953-9945-acbe-532d-0e87e79b4670}">
           <p14:sldIdLst>
             <p14:sldId id="271"/>
           </p14:sldIdLst>
         </p14:section>
-        <p14:section name="Chiusura" id="{c65d09ad-8deb-b620-38dd-0921321bf7bc}">
+        <p14:section name="Chiusura" id="{f4aba050-a422-79ed-61e0-7aac45c396a9}">
           <p14:sldIdLst>
             <p14:sldId id="272"/>
           </p14:sldIdLst>
@@ -1976,7 +1976,7 @@
           <a:p>
             <a:r>
               <a:rPr lang="en-US" dirty="0"/>
-              <a:t>Durante il task: girare tra i banchi, segnarsi le soluzioni interessanti (anche sbagliate) da mostrare nel debrief. Al passo 7 molti non capiranno: è voluto.</a:t>
+              <a:t>Durante il task: entrare a turno nelle stanze separate, segnarsi le soluzioni interessanti (anche sbagliate) da mostrare nel debrief. Al passo 7 molti non capiranno: è voluto.</a:t>
             </a:r>
             <a:endParaRPr lang="en-US" dirty="0"/>
           </a:p>

</xml_diff>

<commit_message>
Numerazione progressiva degli incontri (1-12) nelle soluzioni
Co-Authored-By: Claude Opus 5.5 <noreply@anthropic.com>
Claude-Session: https://claude.ai/code/session_014CzWDFXvYNxqLeD99LSN3G
</commit_message>
<xml_diff>
--- a/L01_python_calcolatrice/slide_complete.pptx
+++ b/L01_python_calcolatrice/slide_complete.pptx
@@ -124,13 +124,13 @@
   <p:extLst>
     <p:ext uri="{521415D9-36F7-43E2-AB2F-B90AF26B5E84}">
       <p14:sectionLst xmlns:p14="http://schemas.microsoft.com/office/powerpoint/2010/main">
-        <p14:section name="Apertura" id="{5843928c-a3c3-eead-f5c3-302e6d6189f9}">
+        <p14:section name="Apertura" id="{086b9459-8b7d-f719-5622-7acd3589edfd}">
           <p14:sldIdLst>
             <p14:sldId id="256"/>
             <p14:sldId id="257"/>
           </p14:sldIdLst>
         </p14:section>
-        <p14:section name="Spiegazione" id="{2a5fcde1-06ec-cadf-0998-2b46cf91bec6}">
+        <p14:section name="Spiegazione" id="{1b78b1fc-b7f0-5049-f5cf-b304b3deb67d}">
           <p14:sldIdLst>
             <p14:sldId id="258"/>
             <p14:sldId id="259"/>
@@ -141,12 +141,12 @@
             <p14:sldId id="264"/>
           </p14:sldIdLst>
         </p14:section>
-        <p14:section name="Task" id="{d9903f4a-3e18-13a6-6375-b391e4b216fc}">
+        <p14:section name="Task" id="{713522ba-c57e-a37b-902f-e303b17cc691}">
           <p14:sldIdLst>
             <p14:sldId id="265"/>
           </p14:sldIdLst>
         </p14:section>
-        <p14:section name="Debrief" id="{8480d438-2595-fe8f-2b17-27579205b938}">
+        <p14:section name="Debrief" id="{9e865aa1-83ba-5866-86a9-1e997301e5b0}">
           <p14:sldIdLst>
             <p14:sldId id="266"/>
             <p14:sldId id="267"/>
@@ -156,12 +156,12 @@
             <p14:sldId id="271"/>
           </p14:sldIdLst>
         </p14:section>
-        <p14:section name="Extra" id="{cb3ebf1c-b43e-a7e3-8565-e5672c34a28f}">
+        <p14:section name="Extra" id="{a506bef5-5ebf-6a1a-8b90-fae7b29a8ff5}">
           <p14:sldIdLst>
             <p14:sldId id="272"/>
           </p14:sldIdLst>
         </p14:section>
-        <p14:section name="Chiusura" id="{78fd95c2-a041-cea5-1649-9105a44d3b76}">
+        <p14:section name="Chiusura" id="{7f994b09-c5b5-7778-6d69-f83b3947d0c8}">
           <p14:sldIdLst>
             <p14:sldId id="273"/>
           </p14:sldIdLst>
@@ -1978,7 +1978,7 @@
           <a:p>
             <a:r>
               <a:rPr lang="en-US" dirty="0"/>
-              <a:t>Mostrare dal vivo: Condividi in alto a destra, aggiungere un indirizzo, scegliere Editor. L'indirizzo vero è solo nella mail, non nei materiali pubblici.</a:t>
+              <a:t>Mostrare dal vivo: Condividi in alto a destra, aggiungere un indirizzo, scegliere Editor. L'indirizzo con +sima2026 arriva nella casella normale ma permette di filtrare lo spam.</a:t>
             </a:r>
             <a:endParaRPr lang="en-US" dirty="0"/>
           </a:p>
@@ -11162,7 +11162,7 @@
                   <a:srgbClr val="B8C4CB"/>
                 </a:solidFill>
               </a:rPr>
-              <a:t>In Colab: Condividi → aggiungete il mio indirizzo (è nella mail) come Editor. Poi scrivetemi quale passo non torna.</a:t>
+              <a:t>In Colab: Condividi → aggiungete andrelorenzon+sima2026@gmail.com come Editor. Poi scrivetemi quale passo non torna.</a:t>
             </a:r>
             <a:endParaRPr lang="en-US" sz="1700" dirty="0"/>
           </a:p>

</xml_diff>

<commit_message>
Soluzioni e slide complete L1 allineate
Co-Authored-By: Claude Opus 5.5 <noreply@anthropic.com>
Claude-Session: https://claude.ai/code/session_014CzWDFXvYNxqLeD99LSN3G
</commit_message>
<xml_diff>
--- a/L01_python_calcolatrice/slide_complete.pptx
+++ b/L01_python_calcolatrice/slide_complete.pptx
@@ -124,13 +124,13 @@
   <p:extLst>
     <p:ext uri="{521415D9-36F7-43E2-AB2F-B90AF26B5E84}">
       <p14:sectionLst xmlns:p14="http://schemas.microsoft.com/office/powerpoint/2010/main">
-        <p14:section name="Apertura" id="{086b9459-8b7d-f719-5622-7acd3589edfd}">
+        <p14:section name="Apertura" id="{48feea5f-3c9c-5e67-b82d-62949b8e1f36}">
           <p14:sldIdLst>
             <p14:sldId id="256"/>
             <p14:sldId id="257"/>
           </p14:sldIdLst>
         </p14:section>
-        <p14:section name="Spiegazione" id="{1b78b1fc-b7f0-5049-f5cf-b304b3deb67d}">
+        <p14:section name="Spiegazione" id="{6717c7ab-39a6-1e9a-e217-5f8aa19c9ff7}">
           <p14:sldIdLst>
             <p14:sldId id="258"/>
             <p14:sldId id="259"/>
@@ -141,12 +141,12 @@
             <p14:sldId id="264"/>
           </p14:sldIdLst>
         </p14:section>
-        <p14:section name="Task" id="{713522ba-c57e-a37b-902f-e303b17cc691}">
+        <p14:section name="Task" id="{ef56983f-5581-d400-b584-3bb7dc25cc14}">
           <p14:sldIdLst>
             <p14:sldId id="265"/>
           </p14:sldIdLst>
         </p14:section>
-        <p14:section name="Debrief" id="{9e865aa1-83ba-5866-86a9-1e997301e5b0}">
+        <p14:section name="Debrief" id="{d8f9496c-fa6d-aab2-1f5d-cc7d983a9542}">
           <p14:sldIdLst>
             <p14:sldId id="266"/>
             <p14:sldId id="267"/>
@@ -156,12 +156,12 @@
             <p14:sldId id="271"/>
           </p14:sldIdLst>
         </p14:section>
-        <p14:section name="Extra" id="{a506bef5-5ebf-6a1a-8b90-fae7b29a8ff5}">
+        <p14:section name="Extra" id="{26974d93-d334-82c7-50ef-4db13953de68}">
           <p14:sldIdLst>
             <p14:sldId id="272"/>
           </p14:sldIdLst>
         </p14:section>
-        <p14:section name="Chiusura" id="{7f994b09-c5b5-7778-6d69-f83b3947d0c8}">
+        <p14:section name="Chiusura" id="{93a40a77-9abb-53ef-4cab-6968d0ff15d5}">
           <p14:sldIdLst>
             <p14:sldId id="273"/>
           </p14:sldIdLst>
@@ -1978,7 +1978,7 @@
           <a:p>
             <a:r>
               <a:rPr lang="en-US" dirty="0"/>
-              <a:t>Mostrare dal vivo: Condividi in alto a destra, aggiungere un indirizzo, scegliere Editor. L'indirizzo con +sima2026 arriva nella casella normale ma permette di filtrare lo spam.</a:t>
+              <a:t>Mostrare dal vivo: Condividi in alto a destra, aggiungere un indirizzo, scegliere Editor. Far vedere dove si trova l'indirizzo: nel promemoria in cima a ogni notebook e nel README.</a:t>
             </a:r>
             <a:endParaRPr lang="en-US" dirty="0"/>
           </a:p>

</xml_diff>